<commit_message>
Name specific users on the problem slide instead of everyone.
The deck and problem brief now answer who the game is for (teen in class, short-period teacher, gamer who already rides) and what fails for each of them today.

Co-Authored-By: Oyren Agent <contact@oyren.ai>
Co-authored-by: Cursor <cursoragent@cursor.com>
</commit_message>
<xml_diff>
--- a/docs/Koroglu-Epic-Game.pptx
+++ b/docs/Koroglu-Epic-Game.pptx
@@ -2162,7 +2162,7 @@
                 <a:ea typeface="Georgia" pitchFamily="34" charset="-122"/>
                 <a:cs typeface="Georgia" pitchFamily="34" charset="-120"/>
               </a:rPr>
-              <a:t>The problem</a:t>
+              <a:t>The user and the problem</a:t>
             </a:r>
             <a:endParaRPr lang="en-US" sz="3600" dirty="0"/>
           </a:p>
@@ -2201,7 +2201,7 @@
                 <a:ea typeface="Georgia" pitchFamily="34" charset="-122"/>
                 <a:cs typeface="Georgia" pitchFamily="34" charset="-120"/>
               </a:rPr>
-              <a:t>Cultural epics stay distant when they stay passive</a:t>
+              <a:t>Who this is for — and what goes wrong for them today. Not “everyone.”</a:t>
             </a:r>
             <a:endParaRPr lang="en-US" sz="1800" dirty="0"/>
           </a:p>
@@ -2244,70 +2244,70 @@
                 <a:ea typeface="Georgia" pitchFamily="34" charset="-122"/>
                 <a:cs typeface="Georgia" pitchFamily="34" charset="-120"/>
               </a:rPr>
-              <a:t>Koroglu is still taught as text, lecture, or a name on a slide</a:t>
-            </a:r>
-            <a:endParaRPr lang="en-US" sz="2000" dirty="0"/>
-          </a:p>
-          <a:p>
-            <a:pPr marL="342900" indent="-342900">
-              <a:spcAft>
-                <a:spcPts val="1000"/>
-              </a:spcAft>
-              <a:buSzPct val="100000"/>
-              <a:buChar char="•"/>
-            </a:pPr>
-            <a:r>
-              <a:rPr lang="en-US" sz="2000" dirty="0">
-                <a:solidFill>
-                  <a:srgbClr val="F4E6C1"/>
-                </a:solidFill>
-                <a:latin typeface="Georgia" pitchFamily="34" charset="0"/>
-                <a:ea typeface="Georgia" pitchFamily="34" charset="-122"/>
-                <a:cs typeface="Georgia" pitchFamily="34" charset="-120"/>
-              </a:rPr>
-              <a:t>Listeners do not do the moral choice, the mounted fight, or the ashik’s verse</a:t>
-            </a:r>
-            <a:endParaRPr lang="en-US" sz="2000" dirty="0"/>
-          </a:p>
-          <a:p>
-            <a:pPr marL="342900" indent="-342900">
-              <a:spcAft>
-                <a:spcPts val="1000"/>
-              </a:spcAft>
-              <a:buSzPct val="100000"/>
-              <a:buChar char="•"/>
-            </a:pPr>
-            <a:r>
-              <a:rPr lang="en-US" sz="2000" dirty="0">
-                <a:solidFill>
-                  <a:srgbClr val="F4E6C1"/>
-                </a:solidFill>
-                <a:latin typeface="Georgia" pitchFamily="34" charset="0"/>
-                <a:ea typeface="Georgia" pitchFamily="34" charset="-122"/>
-                <a:cs typeface="Georgia" pitchFamily="34" charset="-120"/>
-              </a:rPr>
-              <a:t>Young people will not sit through a long recitation</a:t>
-            </a:r>
-            <a:endParaRPr lang="en-US" sz="2000" dirty="0"/>
-          </a:p>
-          <a:p>
-            <a:pPr marL="342900" indent="-342900">
-              <a:spcAft>
-                <a:spcPts val="1000"/>
-              </a:spcAft>
-              <a:buSzPct val="100000"/>
-              <a:buChar char="•"/>
-            </a:pPr>
-            <a:r>
-              <a:rPr lang="en-US" sz="2000" dirty="0">
-                <a:solidFill>
-                  <a:srgbClr val="F4E6C1"/>
-                </a:solidFill>
-                <a:latin typeface="Georgia" pitchFamily="34" charset="0"/>
-                <a:ea typeface="Georgia" pitchFamily="34" charset="-122"/>
-                <a:cs typeface="Georgia" pitchFamily="34" charset="-120"/>
-              </a:rPr>
-              <a:t>Educators need a short, playable proof of the tale’s ethics</a:t>
+              <a:t>A 15–18-year-old in an Azerbaijani / Turkish / Turkmen class or diaspora school: they know the name from a statue or exam. Today they get recitation or Wikipedia — they never ride, never choose, they close the tab.</a:t>
+            </a:r>
+            <a:endParaRPr lang="en-US" sz="2000" dirty="0"/>
+          </a:p>
+          <a:p>
+            <a:pPr marL="342900" indent="-342900">
+              <a:spcAft>
+                <a:spcPts val="1000"/>
+              </a:spcAft>
+              <a:buSzPct val="100000"/>
+              <a:buChar char="•"/>
+            </a:pPr>
+            <a:r>
+              <a:rPr lang="en-US" sz="2000" dirty="0">
+                <a:solidFill>
+                  <a:srgbClr val="F4E6C1"/>
+                </a:solidFill>
+                <a:latin typeface="Georgia" pitchFamily="34" charset="0"/>
+                <a:ea typeface="Georgia" pitchFamily="34" charset="-122"/>
+                <a:cs typeface="Georgia" pitchFamily="34" charset="-120"/>
+              </a:rPr>
+              <a:t>A heritage teacher with one short period: they cannot assign a 400-page dastan. Today they show a slide titled “Epic of Koroglu” and hope a summary sticks. They have no 2-minute thing a student can play.</a:t>
+            </a:r>
+            <a:endParaRPr lang="en-US" sz="2000" dirty="0"/>
+          </a:p>
+          <a:p>
+            <a:pPr marL="342900" indent="-342900">
+              <a:spcAft>
+                <a:spcPts val="1000"/>
+              </a:spcAft>
+              <a:buSzPct val="100000"/>
+              <a:buChar char="•"/>
+            </a:pPr>
+            <a:r>
+              <a:rPr lang="en-US" sz="2000" dirty="0">
+                <a:solidFill>
+                  <a:srgbClr val="F4E6C1"/>
+                </a:solidFill>
+                <a:latin typeface="Georgia" pitchFamily="34" charset="0"/>
+                <a:ea typeface="Georgia" pitchFamily="34" charset="-122"/>
+                <a:cs typeface="Georgia" pitchFamily="34" charset="-120"/>
+              </a:rPr>
+              <a:t>A young gamer who already spends an hour on horses and swords: that hour goes to a made-up kingdom. Their own oral epic sits unused next to the habit that could carry it.</a:t>
+            </a:r>
+            <a:endParaRPr lang="en-US" sz="2000" dirty="0"/>
+          </a:p>
+          <a:p>
+            <a:pPr marL="342900" indent="-342900">
+              <a:spcAft>
+                <a:spcPts val="1000"/>
+              </a:spcAft>
+              <a:buSzPct val="100000"/>
+              <a:buChar char="•"/>
+            </a:pPr>
+            <a:r>
+              <a:rPr lang="en-US" sz="2000" dirty="0">
+                <a:solidFill>
+                  <a:srgbClr val="F4E6C1"/>
+                </a:solidFill>
+                <a:latin typeface="Georgia" pitchFamily="34" charset="0"/>
+                <a:ea typeface="Georgia" pitchFamily="34" charset="-122"/>
+                <a:cs typeface="Georgia" pitchFamily="34" charset="-120"/>
+              </a:rPr>
+              <a:t>The encyclopedia already exists. What fails is practice: no mounted choice, no verse as courage, no moral fork they can get wrong.</a:t>
             </a:r>
             <a:endParaRPr lang="en-US" sz="2000" dirty="0"/>
           </a:p>

</xml_diff>

<commit_message>
Add a Koroğlu intro slide with Gunash Farzaliyev’s name and photo.
The deck now opens on group/project name Koroğlu so judges see who is presenting before the problem slides.

Co-Authored-By: Oyren Agent <contact@oyren.ai>
Co-authored-by: Cursor <cursoragent@cursor.com>
</commit_message>
<xml_diff>
--- a/docs/Koroglu-Epic-Game.pptx
+++ b/docs/Koroglu-Epic-Game.pptx
@@ -15,9 +15,10 @@
     <p:sldId id="263" r:id="rId9"/>
     <p:sldId id="264" r:id="rId10"/>
     <p:sldId id="265" r:id="rId11"/>
+    <p:sldId id="266" r:id="rId12"/>
   </p:sldIdLst>
   <p:notesMasterIdLst>
-    <p:notesMasterId r:id="rId12"/>
+    <p:notesMasterId r:id="rId13"/>
   </p:notesMasterIdLst>
   <p:sldSz cx="12191695" cy="6858000"/>
   <p:notesSz cx="6858000" cy="12191695"/>
@@ -623,6 +624,94 @@
             <a:fld id="{F7021451-1387-4CA6-816F-3879F97B5CBC}" type="slidenum">
               <a:rPr lang="en-US"/>
               <a:t>10</a:t>
+            </a:fld>
+            <a:endParaRPr lang="en-US"/>
+          </a:p>
+        </p:txBody>
+      </p:sp>
+    </p:spTree>
+    <p:extLst>
+      <p:ext uri="{BB962C8B-B14F-4D97-AF65-F5344CB8AC3E}">
+        <p14:creationId xmlns:p14="http://schemas.microsoft.com/office/powerpoint/2010/main" val="1024086991"/>
+      </p:ext>
+    </p:extLst>
+  </p:cSld>
+  <p:clrMapOvr>
+    <a:masterClrMapping/>
+  </p:clrMapOvr>
+</p:notes>
+</file>
+
+<file path=ppt/notesSlides/notesSlide11.xml><?xml version="1.0" encoding="utf-8"?>
+<p:notes xmlns:a="http://schemas.openxmlformats.org/drawingml/2006/main" xmlns:r="http://schemas.openxmlformats.org/officeDocument/2006/relationships" xmlns:p="http://schemas.openxmlformats.org/presentationml/2006/main">
+  <p:cSld>
+    <p:spTree>
+      <p:nvGrpSpPr>
+        <p:cNvPr id="1" name=""/>
+        <p:cNvGrpSpPr/>
+        <p:nvPr/>
+      </p:nvGrpSpPr>
+      <p:grpSpPr>
+        <a:xfrm>
+          <a:off x="0" y="0"/>
+          <a:ext cx="0" cy="0"/>
+          <a:chOff x="0" y="0"/>
+          <a:chExt cx="0" cy="0"/>
+        </a:xfrm>
+      </p:grpSpPr>
+      <p:sp>
+        <p:nvSpPr>
+          <p:cNvPr id="2" name="Slide Image Placeholder 1"/>
+          <p:cNvSpPr>
+            <a:spLocks noGrp="1" noRot="1" noChangeAspect="1"/>
+          </p:cNvSpPr>
+          <p:nvPr>
+            <p:ph type="sldImg"/>
+          </p:nvPr>
+        </p:nvSpPr>
+        <p:spPr/>
+      </p:sp>
+      <p:sp>
+        <p:nvSpPr>
+          <p:cNvPr id="3" name="Notes Placeholder 2"/>
+          <p:cNvSpPr>
+            <a:spLocks noGrp="1"/>
+          </p:cNvSpPr>
+          <p:nvPr>
+            <p:ph type="body" idx="1"/>
+          </p:nvPr>
+        </p:nvSpPr>
+        <p:spPr/>
+        <p:txBody>
+          <a:bodyPr/>
+          <a:lstStyle/>
+          <a:p>
+            <a:r>
+              <a:rPr lang="en-US" dirty="0"/>
+              <a:t/>
+            </a:r>
+            <a:endParaRPr lang="en-US" dirty="0"/>
+          </a:p>
+        </p:txBody>
+      </p:sp>
+      <p:sp>
+        <p:nvSpPr>
+          <p:cNvPr id="4" name="Slide Number Placeholder 3"/>
+          <p:cNvSpPr>
+            <a:spLocks noGrp="1"/>
+          </p:cNvSpPr>
+          <p:nvPr>
+            <p:ph type="sldNum" sz="quarter" idx="10"/>
+          </p:nvPr>
+        </p:nvSpPr>
+        <p:spPr/>
+        <p:txBody>
+          <a:bodyPr/>
+          <a:lstStyle/>
+          <a:p>
+            <a:fld id="{F7021451-1387-4CA6-816F-3879F97B5CBC}" type="slidenum">
+              <a:rPr lang="en-US"/>
+              <a:t>11</a:t>
             </a:fld>
             <a:endParaRPr lang="en-US"/>
           </a:p>
@@ -1684,8 +1773,8 @@
         </p:nvSpPr>
         <p:spPr>
           <a:xfrm>
-            <a:off x="548640" y="256032"/>
-            <a:ext cx="11064240" cy="777240"/>
+            <a:off x="548640" y="1051560"/>
+            <a:ext cx="6949440" cy="868680"/>
           </a:xfrm>
           <a:prstGeom prst="rect">
             <a:avLst/>
@@ -1701,7 +1790,7 @@
               <a:buNone/>
             </a:pPr>
             <a:r>
-              <a:rPr lang="en-US" sz="3600" b="1" dirty="0">
+              <a:rPr lang="en-US" sz="4800" b="1" dirty="0">
                 <a:solidFill>
                   <a:srgbClr val="E8C64A"/>
                 </a:solidFill>
@@ -1709,9 +1798,9 @@
                 <a:ea typeface="Georgia" pitchFamily="34" charset="-122"/>
                 <a:cs typeface="Georgia" pitchFamily="34" charset="-120"/>
               </a:rPr>
-              <a:t>Epic of Koroglu</a:t>
-            </a:r>
-            <a:endParaRPr lang="en-US" sz="3600" dirty="0"/>
+              <a:t>Koroğlu</a:t>
+            </a:r>
+            <a:endParaRPr lang="en-US" sz="4800" dirty="0"/>
           </a:p>
         </p:txBody>
       </p:sp>
@@ -1723,8 +1812,8 @@
         </p:nvSpPr>
         <p:spPr>
           <a:xfrm>
-            <a:off x="548640" y="1024128"/>
-            <a:ext cx="11064240" cy="457200"/>
+            <a:off x="548640" y="1920240"/>
+            <a:ext cx="6949440" cy="365760"/>
           </a:xfrm>
           <a:prstGeom prst="rect">
             <a:avLst/>
@@ -1740,7 +1829,7 @@
               <a:buNone/>
             </a:pPr>
             <a:r>
-              <a:rPr lang="en-US" sz="1800" i="1" dirty="0">
+              <a:rPr lang="en-US" sz="1600" i="1" dirty="0">
                 <a:solidFill>
                   <a:srgbClr val="C9A227"/>
                 </a:solidFill>
@@ -1748,9 +1837,9 @@
                 <a:ea typeface="Georgia" pitchFamily="34" charset="-122"/>
                 <a:cs typeface="Georgia" pitchFamily="34" charset="-120"/>
               </a:rPr>
-              <a:t>A playable Three.js dastan — not a lecture</a:t>
-            </a:r>
-            <a:endParaRPr lang="en-US" sz="1800" dirty="0"/>
+              <a:t>Group name  ·  Project name</a:t>
+            </a:r>
+            <a:endParaRPr lang="en-US" sz="1600" dirty="0"/>
           </a:p>
         </p:txBody>
       </p:sp>
@@ -1762,8 +1851,8 @@
         </p:nvSpPr>
         <p:spPr>
           <a:xfrm>
-            <a:off x="640080" y="1645920"/>
-            <a:ext cx="10972800" cy="4663440"/>
+            <a:off x="548640" y="2606040"/>
+            <a:ext cx="6949440" cy="640080"/>
           </a:xfrm>
           <a:prstGeom prst="rect">
             <a:avLst/>
@@ -1775,91 +1864,87 @@
           <a:bodyPr wrap="square" rtlCol="0" anchor="ctr"/>
           <a:lstStyle/>
           <a:p>
-            <a:pPr marL="342900" indent="-342900">
-              <a:spcAft>
-                <a:spcPts val="1000"/>
-              </a:spcAft>
-              <a:buSzPct val="100000"/>
-              <a:buChar char="•"/>
-            </a:pPr>
-            <a:r>
-              <a:rPr lang="en-US" sz="2000" dirty="0">
-                <a:solidFill>
-                  <a:srgbClr val="F4E6C1"/>
-                </a:solidFill>
-                <a:latin typeface="Georgia" pitchFamily="34" charset="0"/>
-                <a:ea typeface="Georgia" pitchFamily="34" charset="-122"/>
-                <a:cs typeface="Georgia" pitchFamily="34" charset="-120"/>
-              </a:rPr>
-              <a:t>Interactive 3D game of the Turkic Epic of Koroghlu</a:t>
-            </a:r>
-            <a:endParaRPr lang="en-US" sz="2000" dirty="0"/>
-          </a:p>
-          <a:p>
-            <a:pPr marL="342900" indent="-342900">
-              <a:spcAft>
-                <a:spcPts val="1000"/>
-              </a:spcAft>
-              <a:buSzPct val="100000"/>
-              <a:buChar char="•"/>
-            </a:pPr>
-            <a:r>
-              <a:rPr lang="en-US" sz="2000" dirty="0">
-                <a:solidFill>
-                  <a:srgbClr val="F4E6C1"/>
-                </a:solidFill>
-                <a:latin typeface="Georgia" pitchFamily="34" charset="0"/>
-                <a:ea typeface="Georgia" pitchFamily="34" charset="-122"/>
-                <a:cs typeface="Georgia" pitchFamily="34" charset="-120"/>
-              </a:rPr>
-              <a:t>Players learn heritage by riding, choosing, and reciting</a:t>
-            </a:r>
-            <a:endParaRPr lang="en-US" sz="2000" dirty="0"/>
-          </a:p>
-          <a:p>
-            <a:pPr marL="342900" indent="-342900">
-              <a:spcAft>
-                <a:spcPts val="1000"/>
-              </a:spcAft>
-              <a:buSzPct val="100000"/>
-              <a:buChar char="•"/>
-            </a:pPr>
-            <a:r>
-              <a:rPr lang="en-US" sz="2000" dirty="0">
-                <a:solidFill>
-                  <a:srgbClr val="F4E6C1"/>
-                </a:solidFill>
-                <a:latin typeface="Georgia" pitchFamily="34" charset="0"/>
-                <a:ea typeface="Georgia" pitchFamily="34" charset="-122"/>
-                <a:cs typeface="Georgia" pitchFamily="34" charset="-120"/>
-              </a:rPr>
-              <a:t>Hackathon prototype: combat, ally/enemy AI, Nigar, Çamlıbel</a:t>
-            </a:r>
-            <a:endParaRPr lang="en-US" sz="2000" dirty="0"/>
-          </a:p>
-          <a:p>
-            <a:pPr marL="342900" indent="-342900">
-              <a:spcAft>
-                <a:spcPts val="1000"/>
-              </a:spcAft>
-              <a:buSzPct val="100000"/>
-              <a:buChar char="•"/>
-            </a:pPr>
-            <a:r>
-              <a:rPr lang="en-US" sz="2000" dirty="0">
-                <a:solidFill>
-                  <a:srgbClr val="F4E6C1"/>
-                </a:solidFill>
-                <a:latin typeface="Georgia" pitchFamily="34" charset="0"/>
-                <a:ea typeface="Georgia" pitchFamily="34" charset="-122"/>
-                <a:cs typeface="Georgia" pitchFamily="34" charset="-120"/>
-              </a:rPr>
-              <a:t>Canonical tale: Wikipedia — Epic of Koroghlu</a:t>
-            </a:r>
-            <a:endParaRPr lang="en-US" sz="2000" dirty="0"/>
-          </a:p>
-        </p:txBody>
-      </p:sp>
+            <a:pPr indent="0" marL="0">
+              <a:buNone/>
+            </a:pPr>
+            <a:r>
+              <a:rPr lang="en-US" sz="2800" dirty="0">
+                <a:solidFill>
+                  <a:srgbClr val="F4E6C1"/>
+                </a:solidFill>
+                <a:latin typeface="Georgia" pitchFamily="34" charset="0"/>
+                <a:ea typeface="Georgia" pitchFamily="34" charset="-122"/>
+                <a:cs typeface="Georgia" pitchFamily="34" charset="-120"/>
+              </a:rPr>
+              <a:t>My name is Gunash Farzaliyev</a:t>
+            </a:r>
+            <a:endParaRPr lang="en-US" sz="2800" dirty="0"/>
+          </a:p>
+        </p:txBody>
+      </p:sp>
+      <p:sp>
+        <p:nvSpPr>
+          <p:cNvPr id="5" name="Text 3"/>
+          <p:cNvSpPr/>
+          <p:nvPr/>
+        </p:nvSpPr>
+        <p:spPr>
+          <a:xfrm>
+            <a:off x="548640" y="3337560"/>
+            <a:ext cx="6949440" cy="502920"/>
+          </a:xfrm>
+          <a:prstGeom prst="rect">
+            <a:avLst/>
+          </a:prstGeom>
+          <a:noFill/>
+          <a:ln/>
+        </p:spPr>
+        <p:txBody>
+          <a:bodyPr wrap="square" rtlCol="0" anchor="ctr"/>
+          <a:lstStyle/>
+          <a:p>
+            <a:pPr indent="0" marL="0">
+              <a:buNone/>
+            </a:pPr>
+            <a:r>
+              <a:rPr lang="en-US" sz="1800" dirty="0">
+                <a:solidFill>
+                  <a:srgbClr val="C9A227"/>
+                </a:solidFill>
+                <a:latin typeface="Georgia" pitchFamily="34" charset="0"/>
+                <a:ea typeface="Georgia" pitchFamily="34" charset="-122"/>
+                <a:cs typeface="Georgia" pitchFamily="34" charset="-120"/>
+              </a:rPr>
+              <a:t>A playable Three.js dastan of the Epic of Koroghlu</a:t>
+            </a:r>
+            <a:endParaRPr lang="en-US" sz="1800" dirty="0"/>
+          </a:p>
+        </p:txBody>
+      </p:sp>
+      <p:pic>
+        <p:nvPicPr>
+          <p:cNvPr id="6" name="Image 0" descr="/home/oyren/workspace/KorogluDnD/docs/gunash-farzaliyev.jpg">    </p:cNvPr>
+          <p:cNvPicPr>
+            <a:picLocks noChangeAspect="1"/>
+          </p:cNvPicPr>
+          <p:nvPr/>
+        </p:nvPicPr>
+        <p:blipFill>
+          <a:blip r:embed="rId1"/>
+          <a:stretch>
+            <a:fillRect/>
+          </a:stretch>
+        </p:blipFill>
+        <p:spPr>
+          <a:xfrm>
+            <a:off x="7818120" y="411480"/>
+            <a:ext cx="3840480" cy="6035040"/>
+          </a:xfrm>
+          <a:prstGeom prst="rect">
+            <a:avLst/>
+          </a:prstGeom>
+        </p:spPr>
+      </p:pic>
     </p:spTree>
   </p:cSld>
   <p:clrMapOvr>
@@ -1925,6 +2010,243 @@
                 <a:ea typeface="Georgia" pitchFamily="34" charset="-122"/>
                 <a:cs typeface="Georgia" pitchFamily="34" charset="-120"/>
               </a:rPr>
+              <a:t>What to judge</a:t>
+            </a:r>
+            <a:endParaRPr lang="en-US" sz="3600" dirty="0"/>
+          </a:p>
+        </p:txBody>
+      </p:sp>
+      <p:sp>
+        <p:nvSpPr>
+          <p:cNvPr id="3" name="Text 1"/>
+          <p:cNvSpPr/>
+          <p:nvPr/>
+        </p:nvSpPr>
+        <p:spPr>
+          <a:xfrm>
+            <a:off x="548640" y="1024128"/>
+            <a:ext cx="11064240" cy="457200"/>
+          </a:xfrm>
+          <a:prstGeom prst="rect">
+            <a:avLst/>
+          </a:prstGeom>
+          <a:noFill/>
+          <a:ln/>
+        </p:spPr>
+        <p:txBody>
+          <a:bodyPr wrap="square" rtlCol="0" anchor="ctr"/>
+          <a:lstStyle/>
+          <a:p>
+            <a:pPr indent="0" marL="0">
+              <a:buNone/>
+            </a:pPr>
+            <a:r>
+              <a:rPr lang="en-US" sz="1800" i="1" dirty="0">
+                <a:solidFill>
+                  <a:srgbClr val="C9A227"/>
+                </a:solidFill>
+                <a:latin typeface="Georgia" pitchFamily="34" charset="0"/>
+                <a:ea typeface="Georgia" pitchFamily="34" charset="-122"/>
+                <a:cs typeface="Georgia" pitchFamily="34" charset="-120"/>
+              </a:rPr>
+              <a:t>Priority when features conflict</a:t>
+            </a:r>
+            <a:endParaRPr lang="en-US" sz="1800" dirty="0"/>
+          </a:p>
+        </p:txBody>
+      </p:sp>
+      <p:sp>
+        <p:nvSpPr>
+          <p:cNvPr id="4" name="Text 2"/>
+          <p:cNvSpPr/>
+          <p:nvPr/>
+        </p:nvSpPr>
+        <p:spPr>
+          <a:xfrm>
+            <a:off x="640080" y="1645920"/>
+            <a:ext cx="10972800" cy="4663440"/>
+          </a:xfrm>
+          <a:prstGeom prst="rect">
+            <a:avLst/>
+          </a:prstGeom>
+          <a:noFill/>
+          <a:ln/>
+        </p:spPr>
+        <p:txBody>
+          <a:bodyPr wrap="square" rtlCol="0" anchor="ctr"/>
+          <a:lstStyle/>
+          <a:p>
+            <a:pPr marL="342900" indent="-342900">
+              <a:spcAft>
+                <a:spcPts val="1000"/>
+              </a:spcAft>
+              <a:buSzPct val="100000"/>
+              <a:buChar char="•"/>
+            </a:pPr>
+            <a:r>
+              <a:rPr lang="en-US" sz="2000" dirty="0">
+                <a:solidFill>
+                  <a:srgbClr val="F4E6C1"/>
+                </a:solidFill>
+                <a:latin typeface="Georgia" pitchFamily="34" charset="0"/>
+                <a:ea typeface="Georgia" pitchFamily="34" charset="-122"/>
+                <a:cs typeface="Georgia" pitchFamily="34" charset="-120"/>
+              </a:rPr>
+              <a:t>Cultural authenticity first</a:t>
+            </a:r>
+            <a:endParaRPr lang="en-US" sz="2000" dirty="0"/>
+          </a:p>
+          <a:p>
+            <a:pPr marL="342900" indent="-342900">
+              <a:spcAft>
+                <a:spcPts val="1000"/>
+              </a:spcAft>
+              <a:buSzPct val="100000"/>
+              <a:buChar char="•"/>
+            </a:pPr>
+            <a:r>
+              <a:rPr lang="en-US" sz="2000" dirty="0">
+                <a:solidFill>
+                  <a:srgbClr val="F4E6C1"/>
+                </a:solidFill>
+                <a:latin typeface="Georgia" pitchFamily="34" charset="0"/>
+                <a:ea typeface="Georgia" pitchFamily="34" charset="-122"/>
+                <a:cs typeface="Georgia" pitchFamily="34" charset="-120"/>
+              </a:rPr>
+              <a:t>Then a playable combat and AI loop</a:t>
+            </a:r>
+            <a:endParaRPr lang="en-US" sz="2000" dirty="0"/>
+          </a:p>
+          <a:p>
+            <a:pPr marL="342900" indent="-342900">
+              <a:spcAft>
+                <a:spcPts val="1000"/>
+              </a:spcAft>
+              <a:buSzPct val="100000"/>
+              <a:buChar char="•"/>
+            </a:pPr>
+            <a:r>
+              <a:rPr lang="en-US" sz="2000" dirty="0">
+                <a:solidFill>
+                  <a:srgbClr val="F4E6C1"/>
+                </a:solidFill>
+                <a:latin typeface="Georgia" pitchFamily="34" charset="0"/>
+                <a:ea typeface="Georgia" pitchFamily="34" charset="-122"/>
+                <a:cs typeface="Georgia" pitchFamily="34" charset="-120"/>
+              </a:rPr>
+              <a:t>Then generative / branching narrative</a:t>
+            </a:r>
+            <a:endParaRPr lang="en-US" sz="2000" dirty="0"/>
+          </a:p>
+          <a:p>
+            <a:pPr marL="342900" indent="-342900">
+              <a:spcAft>
+                <a:spcPts val="1000"/>
+              </a:spcAft>
+              <a:buSzPct val="100000"/>
+              <a:buChar char="•"/>
+            </a:pPr>
+            <a:r>
+              <a:rPr lang="en-US" sz="2000" dirty="0">
+                <a:solidFill>
+                  <a:srgbClr val="F4E6C1"/>
+                </a:solidFill>
+                <a:latin typeface="Georgia" pitchFamily="34" charset="0"/>
+                <a:ea typeface="Georgia" pitchFamily="34" charset="-122"/>
+                <a:cs typeface="Georgia" pitchFamily="34" charset="-120"/>
+              </a:rPr>
+              <a:t>Then polish</a:t>
+            </a:r>
+            <a:endParaRPr lang="en-US" sz="2000" dirty="0"/>
+          </a:p>
+          <a:p>
+            <a:pPr marL="342900" indent="-342900">
+              <a:spcAft>
+                <a:spcPts val="1000"/>
+              </a:spcAft>
+              <a:buSzPct val="100000"/>
+              <a:buChar char="•"/>
+            </a:pPr>
+            <a:r>
+              <a:rPr lang="en-US" sz="2000" dirty="0">
+                <a:solidFill>
+                  <a:srgbClr val="F4E6C1"/>
+                </a:solidFill>
+                <a:latin typeface="Georgia" pitchFamily="34" charset="0"/>
+                <a:ea typeface="Georgia" pitchFamily="34" charset="-122"/>
+                <a:cs typeface="Georgia" pitchFamily="34" charset="-120"/>
+              </a:rPr>
+              <a:t>This prototype proves the loop in a few minutes of play</a:t>
+            </a:r>
+            <a:endParaRPr lang="en-US" sz="2000" dirty="0"/>
+          </a:p>
+        </p:txBody>
+      </p:sp>
+    </p:spTree>
+  </p:cSld>
+  <p:clrMapOvr>
+    <a:masterClrMapping/>
+  </p:clrMapOvr>
+</p:sld>
+</file>
+
+<file path=ppt/slides/slide11.xml><?xml version="1.0" encoding="utf-8"?>
+<p:sld xmlns:a="http://schemas.openxmlformats.org/drawingml/2006/main" xmlns:r="http://schemas.openxmlformats.org/officeDocument/2006/relationships" xmlns:p="http://schemas.openxmlformats.org/presentationml/2006/main">
+  <p:cSld name="Slide 11">
+    <p:bg>
+      <p:bgPr>
+        <a:solidFill>
+          <a:srgbClr val="1A1208"/>
+        </a:solidFill>
+      </p:bgPr>
+    </p:bg>
+    <p:spTree>
+      <p:nvGrpSpPr>
+        <p:cNvPr id="1" name=""/>
+        <p:cNvGrpSpPr/>
+        <p:nvPr/>
+      </p:nvGrpSpPr>
+      <p:grpSpPr>
+        <a:xfrm>
+          <a:off x="0" y="0"/>
+          <a:ext cx="0" cy="0"/>
+          <a:chOff x="0" y="0"/>
+          <a:chExt cx="0" cy="0"/>
+        </a:xfrm>
+      </p:grpSpPr>
+      <p:sp>
+        <p:nvSpPr>
+          <p:cNvPr id="2" name="Text 0"/>
+          <p:cNvSpPr/>
+          <p:nvPr/>
+        </p:nvSpPr>
+        <p:spPr>
+          <a:xfrm>
+            <a:off x="548640" y="256032"/>
+            <a:ext cx="11064240" cy="777240"/>
+          </a:xfrm>
+          <a:prstGeom prst="rect">
+            <a:avLst/>
+          </a:prstGeom>
+          <a:noFill/>
+          <a:ln/>
+        </p:spPr>
+        <p:txBody>
+          <a:bodyPr wrap="square" rtlCol="0" anchor="ctr"/>
+          <a:lstStyle/>
+          <a:p>
+            <a:pPr indent="0" marL="0">
+              <a:buNone/>
+            </a:pPr>
+            <a:r>
+              <a:rPr lang="en-US" sz="3600" b="1" dirty="0">
+                <a:solidFill>
+                  <a:srgbClr val="E8C64A"/>
+                </a:solidFill>
+                <a:latin typeface="Georgia" pitchFamily="34" charset="0"/>
+                <a:ea typeface="Georgia" pitchFamily="34" charset="-122"/>
+                <a:cs typeface="Georgia" pitchFamily="34" charset="-120"/>
+              </a:rPr>
               <a:t>Sources</a:t>
             </a:r>
             <a:endParaRPr lang="en-US" sz="3600" dirty="0"/>
@@ -2162,7 +2484,7 @@
                 <a:ea typeface="Georgia" pitchFamily="34" charset="-122"/>
                 <a:cs typeface="Georgia" pitchFamily="34" charset="-120"/>
               </a:rPr>
-              <a:t>The user and the problem</a:t>
+              <a:t>Epic of Koroglu</a:t>
             </a:r>
             <a:endParaRPr lang="en-US" sz="3600" dirty="0"/>
           </a:p>
@@ -2201,7 +2523,7 @@
                 <a:ea typeface="Georgia" pitchFamily="34" charset="-122"/>
                 <a:cs typeface="Georgia" pitchFamily="34" charset="-120"/>
               </a:rPr>
-              <a:t>Who this is for — and what goes wrong for them today. Not “everyone.”</a:t>
+              <a:t>A playable Three.js dastan — not a lecture</a:t>
             </a:r>
             <a:endParaRPr lang="en-US" sz="1800" dirty="0"/>
           </a:p>
@@ -2244,70 +2566,70 @@
                 <a:ea typeface="Georgia" pitchFamily="34" charset="-122"/>
                 <a:cs typeface="Georgia" pitchFamily="34" charset="-120"/>
               </a:rPr>
-              <a:t>A 15–18-year-old in an Azerbaijani / Turkish / Turkmen class or diaspora school: they know the name from a statue or exam. Today they get recitation or Wikipedia — they never ride, never choose, they close the tab.</a:t>
-            </a:r>
-            <a:endParaRPr lang="en-US" sz="2000" dirty="0"/>
-          </a:p>
-          <a:p>
-            <a:pPr marL="342900" indent="-342900">
-              <a:spcAft>
-                <a:spcPts val="1000"/>
-              </a:spcAft>
-              <a:buSzPct val="100000"/>
-              <a:buChar char="•"/>
-            </a:pPr>
-            <a:r>
-              <a:rPr lang="en-US" sz="2000" dirty="0">
-                <a:solidFill>
-                  <a:srgbClr val="F4E6C1"/>
-                </a:solidFill>
-                <a:latin typeface="Georgia" pitchFamily="34" charset="0"/>
-                <a:ea typeface="Georgia" pitchFamily="34" charset="-122"/>
-                <a:cs typeface="Georgia" pitchFamily="34" charset="-120"/>
-              </a:rPr>
-              <a:t>A heritage teacher with one short period: they cannot assign a 400-page dastan. Today they show a slide titled “Epic of Koroglu” and hope a summary sticks. They have no 2-minute thing a student can play.</a:t>
-            </a:r>
-            <a:endParaRPr lang="en-US" sz="2000" dirty="0"/>
-          </a:p>
-          <a:p>
-            <a:pPr marL="342900" indent="-342900">
-              <a:spcAft>
-                <a:spcPts val="1000"/>
-              </a:spcAft>
-              <a:buSzPct val="100000"/>
-              <a:buChar char="•"/>
-            </a:pPr>
-            <a:r>
-              <a:rPr lang="en-US" sz="2000" dirty="0">
-                <a:solidFill>
-                  <a:srgbClr val="F4E6C1"/>
-                </a:solidFill>
-                <a:latin typeface="Georgia" pitchFamily="34" charset="0"/>
-                <a:ea typeface="Georgia" pitchFamily="34" charset="-122"/>
-                <a:cs typeface="Georgia" pitchFamily="34" charset="-120"/>
-              </a:rPr>
-              <a:t>A young gamer who already spends an hour on horses and swords: that hour goes to a made-up kingdom. Their own oral epic sits unused next to the habit that could carry it.</a:t>
-            </a:r>
-            <a:endParaRPr lang="en-US" sz="2000" dirty="0"/>
-          </a:p>
-          <a:p>
-            <a:pPr marL="342900" indent="-342900">
-              <a:spcAft>
-                <a:spcPts val="1000"/>
-              </a:spcAft>
-              <a:buSzPct val="100000"/>
-              <a:buChar char="•"/>
-            </a:pPr>
-            <a:r>
-              <a:rPr lang="en-US" sz="2000" dirty="0">
-                <a:solidFill>
-                  <a:srgbClr val="F4E6C1"/>
-                </a:solidFill>
-                <a:latin typeface="Georgia" pitchFamily="34" charset="0"/>
-                <a:ea typeface="Georgia" pitchFamily="34" charset="-122"/>
-                <a:cs typeface="Georgia" pitchFamily="34" charset="-120"/>
-              </a:rPr>
-              <a:t>The encyclopedia already exists. What fails is practice: no mounted choice, no verse as courage, no moral fork they can get wrong.</a:t>
+              <a:t>Interactive 3D game of the Turkic Epic of Koroghlu</a:t>
+            </a:r>
+            <a:endParaRPr lang="en-US" sz="2000" dirty="0"/>
+          </a:p>
+          <a:p>
+            <a:pPr marL="342900" indent="-342900">
+              <a:spcAft>
+                <a:spcPts val="1000"/>
+              </a:spcAft>
+              <a:buSzPct val="100000"/>
+              <a:buChar char="•"/>
+            </a:pPr>
+            <a:r>
+              <a:rPr lang="en-US" sz="2000" dirty="0">
+                <a:solidFill>
+                  <a:srgbClr val="F4E6C1"/>
+                </a:solidFill>
+                <a:latin typeface="Georgia" pitchFamily="34" charset="0"/>
+                <a:ea typeface="Georgia" pitchFamily="34" charset="-122"/>
+                <a:cs typeface="Georgia" pitchFamily="34" charset="-120"/>
+              </a:rPr>
+              <a:t>Players learn heritage by riding, choosing, and reciting</a:t>
+            </a:r>
+            <a:endParaRPr lang="en-US" sz="2000" dirty="0"/>
+          </a:p>
+          <a:p>
+            <a:pPr marL="342900" indent="-342900">
+              <a:spcAft>
+                <a:spcPts val="1000"/>
+              </a:spcAft>
+              <a:buSzPct val="100000"/>
+              <a:buChar char="•"/>
+            </a:pPr>
+            <a:r>
+              <a:rPr lang="en-US" sz="2000" dirty="0">
+                <a:solidFill>
+                  <a:srgbClr val="F4E6C1"/>
+                </a:solidFill>
+                <a:latin typeface="Georgia" pitchFamily="34" charset="0"/>
+                <a:ea typeface="Georgia" pitchFamily="34" charset="-122"/>
+                <a:cs typeface="Georgia" pitchFamily="34" charset="-120"/>
+              </a:rPr>
+              <a:t>Hackathon prototype: combat, ally/enemy AI, Nigar, Çamlıbel</a:t>
+            </a:r>
+            <a:endParaRPr lang="en-US" sz="2000" dirty="0"/>
+          </a:p>
+          <a:p>
+            <a:pPr marL="342900" indent="-342900">
+              <a:spcAft>
+                <a:spcPts val="1000"/>
+              </a:spcAft>
+              <a:buSzPct val="100000"/>
+              <a:buChar char="•"/>
+            </a:pPr>
+            <a:r>
+              <a:rPr lang="en-US" sz="2000" dirty="0">
+                <a:solidFill>
+                  <a:srgbClr val="F4E6C1"/>
+                </a:solidFill>
+                <a:latin typeface="Georgia" pitchFamily="34" charset="0"/>
+                <a:ea typeface="Georgia" pitchFamily="34" charset="-122"/>
+                <a:cs typeface="Georgia" pitchFamily="34" charset="-120"/>
+              </a:rPr>
+              <a:t>Canonical tale: Wikipedia — Epic of Koroghlu</a:t>
             </a:r>
             <a:endParaRPr lang="en-US" sz="2000" dirty="0"/>
           </a:p>
@@ -2378,7 +2700,7 @@
                 <a:ea typeface="Georgia" pitchFamily="34" charset="-122"/>
                 <a:cs typeface="Georgia" pitchFamily="34" charset="-120"/>
               </a:rPr>
-              <a:t>The outcome</a:t>
+              <a:t>The user and the problem</a:t>
             </a:r>
             <a:endParaRPr lang="en-US" sz="3600" dirty="0"/>
           </a:p>
@@ -2417,7 +2739,7 @@
                 <a:ea typeface="Georgia" pitchFamily="34" charset="-122"/>
                 <a:cs typeface="Georgia" pitchFamily="34" charset="-120"/>
               </a:rPr>
-              <a:t>Culture sticks because it was played</a:t>
+              <a:t>Who this is for — and what goes wrong for them today. Not “everyone.”</a:t>
             </a:r>
             <a:endParaRPr lang="en-US" sz="1800" dirty="0"/>
           </a:p>
@@ -2460,70 +2782,70 @@
                 <a:ea typeface="Georgia" pitchFamily="34" charset="-122"/>
                 <a:cs typeface="Georgia" pitchFamily="34" charset="-120"/>
               </a:rPr>
-              <a:t>Act the MVP loop: blinded father → allies → combat → rescue Nigar → take the keep</a:t>
-            </a:r>
-            <a:endParaRPr lang="en-US" sz="2000" dirty="0"/>
-          </a:p>
-          <a:p>
-            <a:pPr marL="342900" indent="-342900">
-              <a:spcAft>
-                <a:spcPts val="1000"/>
-              </a:spcAft>
-              <a:buSzPct val="100000"/>
-              <a:buChar char="•"/>
-            </a:pPr>
-            <a:r>
-              <a:rPr lang="en-US" sz="2000" dirty="0">
-                <a:solidFill>
-                  <a:srgbClr val="F4E6C1"/>
-                </a:solidFill>
-                <a:latin typeface="Georgia" pitchFamily="34" charset="0"/>
-                <a:ea typeface="Georgia" pitchFamily="34" charset="-122"/>
-                <a:cs typeface="Georgia" pitchFamily="34" charset="-120"/>
-              </a:rPr>
-              <a:t>Values practiced in play: justice over revenge, protect the weak, poetry as courage</a:t>
-            </a:r>
-            <a:endParaRPr lang="en-US" sz="2000" dirty="0"/>
-          </a:p>
-          <a:p>
-            <a:pPr marL="342900" indent="-342900">
-              <a:spcAft>
-                <a:spcPts val="1000"/>
-              </a:spcAft>
-              <a:buSzPct val="100000"/>
-              <a:buChar char="•"/>
-            </a:pPr>
-            <a:r>
-              <a:rPr lang="en-US" sz="2000" dirty="0">
-                <a:solidFill>
-                  <a:srgbClr val="F4E6C1"/>
-                </a:solidFill>
-                <a:latin typeface="Georgia" pitchFamily="34" charset="0"/>
-                <a:ea typeface="Georgia" pitchFamily="34" charset="-122"/>
-                <a:cs typeface="Georgia" pitchFamily="34" charset="-120"/>
-              </a:rPr>
-              <a:t>Proposal benchmark: higher heritage retention vs text-only learning</a:t>
-            </a:r>
-            <a:endParaRPr lang="en-US" sz="2000" dirty="0"/>
-          </a:p>
-          <a:p>
-            <a:pPr marL="342900" indent="-342900">
-              <a:spcAft>
-                <a:spcPts val="1000"/>
-              </a:spcAft>
-              <a:buSzPct val="100000"/>
-              <a:buChar char="•"/>
-            </a:pPr>
-            <a:r>
-              <a:rPr lang="en-US" sz="2000" dirty="0">
-                <a:solidFill>
-                  <a:srgbClr val="F4E6C1"/>
-                </a:solidFill>
-                <a:latin typeface="Georgia" pitchFamily="34" charset="0"/>
-                <a:ea typeface="Georgia" pitchFamily="34" charset="-122"/>
-                <a:cs typeface="Georgia" pitchFamily="34" charset="-120"/>
-              </a:rPr>
-              <a:t>Visible success: ally joins, verse slows a tyrant’s rider, Nigar is free, gate opens</a:t>
+              <a:t>A 15–18-year-old in an Azerbaijani / Turkish / Turkmen class or diaspora school: they know the name from a statue or exam. Today they get recitation or Wikipedia — they never ride, never choose, they close the tab.</a:t>
+            </a:r>
+            <a:endParaRPr lang="en-US" sz="2000" dirty="0"/>
+          </a:p>
+          <a:p>
+            <a:pPr marL="342900" indent="-342900">
+              <a:spcAft>
+                <a:spcPts val="1000"/>
+              </a:spcAft>
+              <a:buSzPct val="100000"/>
+              <a:buChar char="•"/>
+            </a:pPr>
+            <a:r>
+              <a:rPr lang="en-US" sz="2000" dirty="0">
+                <a:solidFill>
+                  <a:srgbClr val="F4E6C1"/>
+                </a:solidFill>
+                <a:latin typeface="Georgia" pitchFamily="34" charset="0"/>
+                <a:ea typeface="Georgia" pitchFamily="34" charset="-122"/>
+                <a:cs typeface="Georgia" pitchFamily="34" charset="-120"/>
+              </a:rPr>
+              <a:t>A heritage teacher with one short period: they cannot assign a 400-page dastan. Today they show a slide titled “Epic of Koroglu” and hope a summary sticks. They have no 2-minute thing a student can play.</a:t>
+            </a:r>
+            <a:endParaRPr lang="en-US" sz="2000" dirty="0"/>
+          </a:p>
+          <a:p>
+            <a:pPr marL="342900" indent="-342900">
+              <a:spcAft>
+                <a:spcPts val="1000"/>
+              </a:spcAft>
+              <a:buSzPct val="100000"/>
+              <a:buChar char="•"/>
+            </a:pPr>
+            <a:r>
+              <a:rPr lang="en-US" sz="2000" dirty="0">
+                <a:solidFill>
+                  <a:srgbClr val="F4E6C1"/>
+                </a:solidFill>
+                <a:latin typeface="Georgia" pitchFamily="34" charset="0"/>
+                <a:ea typeface="Georgia" pitchFamily="34" charset="-122"/>
+                <a:cs typeface="Georgia" pitchFamily="34" charset="-120"/>
+              </a:rPr>
+              <a:t>A young gamer who already spends an hour on horses and swords: that hour goes to a made-up kingdom. Their own oral epic sits unused next to the habit that could carry it.</a:t>
+            </a:r>
+            <a:endParaRPr lang="en-US" sz="2000" dirty="0"/>
+          </a:p>
+          <a:p>
+            <a:pPr marL="342900" indent="-342900">
+              <a:spcAft>
+                <a:spcPts val="1000"/>
+              </a:spcAft>
+              <a:buSzPct val="100000"/>
+              <a:buChar char="•"/>
+            </a:pPr>
+            <a:r>
+              <a:rPr lang="en-US" sz="2000" dirty="0">
+                <a:solidFill>
+                  <a:srgbClr val="F4E6C1"/>
+                </a:solidFill>
+                <a:latin typeface="Georgia" pitchFamily="34" charset="0"/>
+                <a:ea typeface="Georgia" pitchFamily="34" charset="-122"/>
+                <a:cs typeface="Georgia" pitchFamily="34" charset="-120"/>
+              </a:rPr>
+              <a:t>The encyclopedia already exists. What fails is practice: no mounted choice, no verse as courage, no moral fork they can get wrong.</a:t>
             </a:r>
             <a:endParaRPr lang="en-US" sz="2000" dirty="0"/>
           </a:p>
@@ -2594,7 +2916,7 @@
                 <a:ea typeface="Georgia" pitchFamily="34" charset="-122"/>
                 <a:cs typeface="Georgia" pitchFamily="34" charset="-120"/>
               </a:rPr>
-              <a:t>Core player loop</a:t>
+              <a:t>The outcome</a:t>
             </a:r>
             <a:endParaRPr lang="en-US" sz="3600" dirty="0"/>
           </a:p>
@@ -2633,7 +2955,7 @@
                 <a:ea typeface="Georgia" pitchFamily="34" charset="-122"/>
                 <a:cs typeface="Georgia" pitchFamily="34" charset="-120"/>
               </a:rPr>
-              <a:t>Ship this arc — do not invent a conflicting plot</a:t>
+              <a:t>Culture sticks because it was played</a:t>
             </a:r>
             <a:endParaRPr lang="en-US" sz="1800" dirty="0"/>
           </a:p>
@@ -2676,91 +2998,70 @@
                 <a:ea typeface="Georgia" pitchFamily="34" charset="-122"/>
                 <a:cs typeface="Georgia" pitchFamily="34" charset="-120"/>
               </a:rPr>
-              <a:t>1. Ali Kishi is blinded for telling the truth about the colt Kırat</a:t>
-            </a:r>
-            <a:endParaRPr lang="en-US" sz="2000" dirty="0"/>
-          </a:p>
-          <a:p>
-            <a:pPr marL="342900" indent="-342900">
-              <a:spcAft>
-                <a:spcPts val="1000"/>
-              </a:spcAft>
-              <a:buSzPct val="100000"/>
-              <a:buChar char="•"/>
-            </a:pPr>
-            <a:r>
-              <a:rPr lang="en-US" sz="2000" dirty="0">
-                <a:solidFill>
-                  <a:srgbClr val="F4E6C1"/>
-                </a:solidFill>
-                <a:latin typeface="Georgia" pitchFamily="34" charset="0"/>
-                <a:ea typeface="Georgia" pitchFamily="34" charset="-122"/>
-                <a:cs typeface="Georgia" pitchFamily="34" charset="-120"/>
-              </a:rPr>
-              <a:t>2. Recruit ally minds: Deli Hasan, Ayvaz</a:t>
-            </a:r>
-            <a:endParaRPr lang="en-US" sz="2000" dirty="0"/>
-          </a:p>
-          <a:p>
-            <a:pPr marL="342900" indent="-342900">
-              <a:spcAft>
-                <a:spcPts val="1000"/>
-              </a:spcAft>
-              <a:buSzPct val="100000"/>
-              <a:buChar char="•"/>
-            </a:pPr>
-            <a:r>
-              <a:rPr lang="en-US" sz="2000" dirty="0">
-                <a:solidFill>
-                  <a:srgbClr val="F4E6C1"/>
-                </a:solidFill>
-                <a:latin typeface="Georgia" pitchFamily="34" charset="0"/>
-                <a:ea typeface="Georgia" pitchFamily="34" charset="-122"/>
-                <a:cs typeface="Georgia" pitchFamily="34" charset="-120"/>
-              </a:rPr>
-              <a:t>3. Mounted combat: saber and verse against Bolu Bey’s riders</a:t>
-            </a:r>
-            <a:endParaRPr lang="en-US" sz="2000" dirty="0"/>
-          </a:p>
-          <a:p>
-            <a:pPr marL="342900" indent="-342900">
-              <a:spcAft>
-                <a:spcPts val="1000"/>
-              </a:spcAft>
-              <a:buSzPct val="100000"/>
-              <a:buChar char="•"/>
-            </a:pPr>
-            <a:r>
-              <a:rPr lang="en-US" sz="2000" dirty="0">
-                <a:solidFill>
-                  <a:srgbClr val="F4E6C1"/>
-                </a:solidFill>
-                <a:latin typeface="Georgia" pitchFamily="34" charset="0"/>
-                <a:ea typeface="Georgia" pitchFamily="34" charset="-122"/>
-                <a:cs typeface="Georgia" pitchFamily="34" charset="-120"/>
-              </a:rPr>
-              <a:t>4. Rescue Nigar from the captain</a:t>
-            </a:r>
-            <a:endParaRPr lang="en-US" sz="2000" dirty="0"/>
-          </a:p>
-          <a:p>
-            <a:pPr marL="342900" indent="-342900">
-              <a:spcAft>
-                <a:spcPts val="1000"/>
-              </a:spcAft>
-              <a:buSzPct val="100000"/>
-              <a:buChar char="•"/>
-            </a:pPr>
-            <a:r>
-              <a:rPr lang="en-US" sz="2000" dirty="0">
-                <a:solidFill>
-                  <a:srgbClr val="F4E6C1"/>
-                </a:solidFill>
-                <a:latin typeface="Georgia" pitchFamily="34" charset="0"/>
-                <a:ea typeface="Georgia" pitchFamily="34" charset="-122"/>
-                <a:cs typeface="Georgia" pitchFamily="34" charset="-120"/>
-              </a:rPr>
-              <a:t>5. Capture Çamlıbel as a home for the just — not a trophy</a:t>
+              <a:t>Act the MVP loop: blinded father → allies → combat → rescue Nigar → take the keep</a:t>
+            </a:r>
+            <a:endParaRPr lang="en-US" sz="2000" dirty="0"/>
+          </a:p>
+          <a:p>
+            <a:pPr marL="342900" indent="-342900">
+              <a:spcAft>
+                <a:spcPts val="1000"/>
+              </a:spcAft>
+              <a:buSzPct val="100000"/>
+              <a:buChar char="•"/>
+            </a:pPr>
+            <a:r>
+              <a:rPr lang="en-US" sz="2000" dirty="0">
+                <a:solidFill>
+                  <a:srgbClr val="F4E6C1"/>
+                </a:solidFill>
+                <a:latin typeface="Georgia" pitchFamily="34" charset="0"/>
+                <a:ea typeface="Georgia" pitchFamily="34" charset="-122"/>
+                <a:cs typeface="Georgia" pitchFamily="34" charset="-120"/>
+              </a:rPr>
+              <a:t>Values practiced in play: justice over revenge, protect the weak, poetry as courage</a:t>
+            </a:r>
+            <a:endParaRPr lang="en-US" sz="2000" dirty="0"/>
+          </a:p>
+          <a:p>
+            <a:pPr marL="342900" indent="-342900">
+              <a:spcAft>
+                <a:spcPts val="1000"/>
+              </a:spcAft>
+              <a:buSzPct val="100000"/>
+              <a:buChar char="•"/>
+            </a:pPr>
+            <a:r>
+              <a:rPr lang="en-US" sz="2000" dirty="0">
+                <a:solidFill>
+                  <a:srgbClr val="F4E6C1"/>
+                </a:solidFill>
+                <a:latin typeface="Georgia" pitchFamily="34" charset="0"/>
+                <a:ea typeface="Georgia" pitchFamily="34" charset="-122"/>
+                <a:cs typeface="Georgia" pitchFamily="34" charset="-120"/>
+              </a:rPr>
+              <a:t>Proposal benchmark: higher heritage retention vs text-only learning</a:t>
+            </a:r>
+            <a:endParaRPr lang="en-US" sz="2000" dirty="0"/>
+          </a:p>
+          <a:p>
+            <a:pPr marL="342900" indent="-342900">
+              <a:spcAft>
+                <a:spcPts val="1000"/>
+              </a:spcAft>
+              <a:buSzPct val="100000"/>
+              <a:buChar char="•"/>
+            </a:pPr>
+            <a:r>
+              <a:rPr lang="en-US" sz="2000" dirty="0">
+                <a:solidFill>
+                  <a:srgbClr val="F4E6C1"/>
+                </a:solidFill>
+                <a:latin typeface="Georgia" pitchFamily="34" charset="0"/>
+                <a:ea typeface="Georgia" pitchFamily="34" charset="-122"/>
+                <a:cs typeface="Georgia" pitchFamily="34" charset="-120"/>
+              </a:rPr>
+              <a:t>Visible success: ally joins, verse slows a tyrant’s rider, Nigar is free, gate opens</a:t>
             </a:r>
             <a:endParaRPr lang="en-US" sz="2000" dirty="0"/>
           </a:p>
@@ -2831,7 +3132,7 @@
                 <a:ea typeface="Georgia" pitchFamily="34" charset="-122"/>
                 <a:cs typeface="Georgia" pitchFamily="34" charset="-120"/>
               </a:rPr>
-              <a:t>Signature mechanics</a:t>
+              <a:t>Core player loop</a:t>
             </a:r>
             <a:endParaRPr lang="en-US" sz="3600" dirty="0"/>
           </a:p>
@@ -2870,7 +3171,7 @@
                 <a:ea typeface="Georgia" pitchFamily="34" charset="-122"/>
                 <a:cs typeface="Georgia" pitchFamily="34" charset="-120"/>
               </a:rPr>
-              <a:t>What makes this Koroglu, not a generic horse fighter</a:t>
+              <a:t>Ship this arc — do not invent a conflicting plot</a:t>
             </a:r>
             <a:endParaRPr lang="en-US" sz="1800" dirty="0"/>
           </a:p>
@@ -2913,91 +3214,91 @@
                 <a:ea typeface="Georgia" pitchFamily="34" charset="-122"/>
                 <a:cs typeface="Georgia" pitchFamily="34" charset="-120"/>
               </a:rPr>
-              <a:t>Mounted riding in a valley (click or Ride N / W / S / E)</a:t>
-            </a:r>
-            <a:endParaRPr lang="en-US" sz="2000" dirty="0"/>
-          </a:p>
-          <a:p>
-            <a:pPr marL="342900" indent="-342900">
-              <a:spcAft>
-                <a:spcPts val="1000"/>
-              </a:spcAft>
-              <a:buSzPct val="100000"/>
-              <a:buChar char="•"/>
-            </a:pPr>
-            <a:r>
-              <a:rPr lang="en-US" sz="2000" dirty="0">
-                <a:solidFill>
-                  <a:srgbClr val="F4E6C1"/>
-                </a:solidFill>
-                <a:latin typeface="Georgia" pitchFamily="34" charset="0"/>
-                <a:ea typeface="Georgia" pitchFamily="34" charset="-122"/>
-                <a:cs typeface="Georgia" pitchFamily="34" charset="-120"/>
-              </a:rPr>
-              <a:t>Sword combat with hit timing</a:t>
-            </a:r>
-            <a:endParaRPr lang="en-US" sz="2000" dirty="0"/>
-          </a:p>
-          <a:p>
-            <a:pPr marL="342900" indent="-342900">
-              <a:spcAft>
-                <a:spcPts val="1000"/>
-              </a:spcAft>
-              <a:buSzPct val="100000"/>
-              <a:buChar char="•"/>
-            </a:pPr>
-            <a:r>
-              <a:rPr lang="en-US" sz="2000" dirty="0">
-                <a:solidFill>
-                  <a:srgbClr val="F4E6C1"/>
-                </a:solidFill>
-                <a:latin typeface="Georgia" pitchFamily="34" charset="0"/>
-                <a:ea typeface="Georgia" pitchFamily="34" charset="-122"/>
-                <a:cs typeface="Georgia" pitchFamily="34" charset="-120"/>
-              </a:rPr>
-              <a:t>Poetry combat: recited verses demoralize enemies</a:t>
-            </a:r>
-            <a:endParaRPr lang="en-US" sz="2000" dirty="0"/>
-          </a:p>
-          <a:p>
-            <a:pPr marL="342900" indent="-342900">
-              <a:spcAft>
-                <a:spcPts val="1000"/>
-              </a:spcAft>
-              <a:buSzPct val="100000"/>
-              <a:buChar char="•"/>
-            </a:pPr>
-            <a:r>
-              <a:rPr lang="en-US" sz="2000" dirty="0">
-                <a:solidFill>
-                  <a:srgbClr val="F4E6C1"/>
-                </a:solidFill>
-                <a:latin typeface="Georgia" pitchFamily="34" charset="0"/>
-                <a:ea typeface="Georgia" pitchFamily="34" charset="-122"/>
-                <a:cs typeface="Georgia" pitchFamily="34" charset="-120"/>
-              </a:rPr>
-              <a:t>Ashik saz heals those who stand with song</a:t>
-            </a:r>
-            <a:endParaRPr lang="en-US" sz="2000" dirty="0"/>
-          </a:p>
-          <a:p>
-            <a:pPr marL="342900" indent="-342900">
-              <a:spcAft>
-                <a:spcPts val="1000"/>
-              </a:spcAft>
-              <a:buSzPct val="100000"/>
-              <a:buChar char="•"/>
-            </a:pPr>
-            <a:r>
-              <a:rPr lang="en-US" sz="2000" dirty="0">
-                <a:solidFill>
-                  <a:srgbClr val="F4E6C1"/>
-                </a:solidFill>
-                <a:latin typeface="Georgia" pitchFamily="34" charset="0"/>
-                <a:ea typeface="Georgia" pitchFamily="34" charset="-122"/>
-                <a:cs typeface="Georgia" pitchFamily="34" charset="-120"/>
-              </a:rPr>
-              <a:t>Moral counsel with the band before the last riders</a:t>
+              <a:t>1. Ali Kishi is blinded for telling the truth about the colt Kırat</a:t>
+            </a:r>
+            <a:endParaRPr lang="en-US" sz="2000" dirty="0"/>
+          </a:p>
+          <a:p>
+            <a:pPr marL="342900" indent="-342900">
+              <a:spcAft>
+                <a:spcPts val="1000"/>
+              </a:spcAft>
+              <a:buSzPct val="100000"/>
+              <a:buChar char="•"/>
+            </a:pPr>
+            <a:r>
+              <a:rPr lang="en-US" sz="2000" dirty="0">
+                <a:solidFill>
+                  <a:srgbClr val="F4E6C1"/>
+                </a:solidFill>
+                <a:latin typeface="Georgia" pitchFamily="34" charset="0"/>
+                <a:ea typeface="Georgia" pitchFamily="34" charset="-122"/>
+                <a:cs typeface="Georgia" pitchFamily="34" charset="-120"/>
+              </a:rPr>
+              <a:t>2. Recruit ally minds: Deli Hasan, Ayvaz</a:t>
+            </a:r>
+            <a:endParaRPr lang="en-US" sz="2000" dirty="0"/>
+          </a:p>
+          <a:p>
+            <a:pPr marL="342900" indent="-342900">
+              <a:spcAft>
+                <a:spcPts val="1000"/>
+              </a:spcAft>
+              <a:buSzPct val="100000"/>
+              <a:buChar char="•"/>
+            </a:pPr>
+            <a:r>
+              <a:rPr lang="en-US" sz="2000" dirty="0">
+                <a:solidFill>
+                  <a:srgbClr val="F4E6C1"/>
+                </a:solidFill>
+                <a:latin typeface="Georgia" pitchFamily="34" charset="0"/>
+                <a:ea typeface="Georgia" pitchFamily="34" charset="-122"/>
+                <a:cs typeface="Georgia" pitchFamily="34" charset="-120"/>
+              </a:rPr>
+              <a:t>3. Mounted combat: saber and verse against Bolu Bey’s riders</a:t>
+            </a:r>
+            <a:endParaRPr lang="en-US" sz="2000" dirty="0"/>
+          </a:p>
+          <a:p>
+            <a:pPr marL="342900" indent="-342900">
+              <a:spcAft>
+                <a:spcPts val="1000"/>
+              </a:spcAft>
+              <a:buSzPct val="100000"/>
+              <a:buChar char="•"/>
+            </a:pPr>
+            <a:r>
+              <a:rPr lang="en-US" sz="2000" dirty="0">
+                <a:solidFill>
+                  <a:srgbClr val="F4E6C1"/>
+                </a:solidFill>
+                <a:latin typeface="Georgia" pitchFamily="34" charset="0"/>
+                <a:ea typeface="Georgia" pitchFamily="34" charset="-122"/>
+                <a:cs typeface="Georgia" pitchFamily="34" charset="-120"/>
+              </a:rPr>
+              <a:t>4. Rescue Nigar from the captain</a:t>
+            </a:r>
+            <a:endParaRPr lang="en-US" sz="2000" dirty="0"/>
+          </a:p>
+          <a:p>
+            <a:pPr marL="342900" indent="-342900">
+              <a:spcAft>
+                <a:spcPts val="1000"/>
+              </a:spcAft>
+              <a:buSzPct val="100000"/>
+              <a:buChar char="•"/>
+            </a:pPr>
+            <a:r>
+              <a:rPr lang="en-US" sz="2000" dirty="0">
+                <a:solidFill>
+                  <a:srgbClr val="F4E6C1"/>
+                </a:solidFill>
+                <a:latin typeface="Georgia" pitchFamily="34" charset="0"/>
+                <a:ea typeface="Georgia" pitchFamily="34" charset="-122"/>
+                <a:cs typeface="Georgia" pitchFamily="34" charset="-120"/>
+              </a:rPr>
+              <a:t>5. Capture Çamlıbel as a home for the just — not a trophy</a:t>
             </a:r>
             <a:endParaRPr lang="en-US" sz="2000" dirty="0"/>
           </a:p>
@@ -3068,7 +3369,7 @@
                 <a:ea typeface="Georgia" pitchFamily="34" charset="-122"/>
                 <a:cs typeface="Georgia" pitchFamily="34" charset="-120"/>
               </a:rPr>
-              <a:t>AI in this build</a:t>
+              <a:t>Signature mechanics</a:t>
             </a:r>
             <a:endParaRPr lang="en-US" sz="3600" dirty="0"/>
           </a:p>
@@ -3107,7 +3408,7 @@
                 <a:ea typeface="Georgia" pitchFamily="34" charset="-122"/>
                 <a:cs typeface="Georgia" pitchFamily="34" charset="-120"/>
               </a:rPr>
-              <a:t>Reactive agents, not a cutscene</a:t>
+              <a:t>What makes this Koroglu, not a generic horse fighter</a:t>
             </a:r>
             <a:endParaRPr lang="en-US" sz="1800" dirty="0"/>
           </a:p>
@@ -3150,91 +3451,91 @@
                 <a:ea typeface="Georgia" pitchFamily="34" charset="-122"/>
                 <a:cs typeface="Georgia" pitchFamily="34" charset="-120"/>
               </a:rPr>
-              <a:t>Ally AI: Deli Hasan and Ayvaz fight at your shoulder</a:t>
-            </a:r>
-            <a:endParaRPr lang="en-US" sz="2000" dirty="0"/>
-          </a:p>
-          <a:p>
-            <a:pPr marL="342900" indent="-342900">
-              <a:spcAft>
-                <a:spcPts val="1000"/>
-              </a:spcAft>
-              <a:buSzPct val="100000"/>
-              <a:buChar char="•"/>
-            </a:pPr>
-            <a:r>
-              <a:rPr lang="en-US" sz="2000" dirty="0">
-                <a:solidFill>
-                  <a:srgbClr val="F4E6C1"/>
-                </a:solidFill>
-                <a:latin typeface="Georgia" pitchFamily="34" charset="0"/>
-                <a:ea typeface="Georgia" pitchFamily="34" charset="-122"/>
-                <a:cs typeface="Georgia" pitchFamily="34" charset="-120"/>
-              </a:rPr>
-              <a:t>Enemy AI: tax riders, sergeant, captain, last keep riders</a:t>
-            </a:r>
-            <a:endParaRPr lang="en-US" sz="2000" dirty="0"/>
-          </a:p>
-          <a:p>
-            <a:pPr marL="342900" indent="-342900">
-              <a:spcAft>
-                <a:spcPts val="1000"/>
-              </a:spcAft>
-              <a:buSzPct val="100000"/>
-              <a:buChar char="•"/>
-            </a:pPr>
-            <a:r>
-              <a:rPr lang="en-US" sz="2000" dirty="0">
-                <a:solidFill>
-                  <a:srgbClr val="F4E6C1"/>
-                </a:solidFill>
-                <a:latin typeface="Georgia" pitchFamily="34" charset="0"/>
-                <a:ea typeface="Georgia" pitchFamily="34" charset="-122"/>
-                <a:cs typeface="Georgia" pitchFamily="34" charset="-120"/>
-              </a:rPr>
-              <a:t>Adaptive pressure: verse slows them; they close when you linger</a:t>
-            </a:r>
-            <a:endParaRPr lang="en-US" sz="2000" dirty="0"/>
-          </a:p>
-          <a:p>
-            <a:pPr marL="342900" indent="-342900">
-              <a:spcAft>
-                <a:spcPts val="1000"/>
-              </a:spcAft>
-              <a:buSzPct val="100000"/>
-              <a:buChar char="•"/>
-            </a:pPr>
-            <a:r>
-              <a:rPr lang="en-US" sz="2000" dirty="0">
-                <a:solidFill>
-                  <a:srgbClr val="F4E6C1"/>
-                </a:solidFill>
-                <a:latin typeface="Georgia" pitchFamily="34" charset="0"/>
-                <a:ea typeface="Georgia" pitchFamily="34" charset="-122"/>
-                <a:cs typeface="Georgia" pitchFamily="34" charset="-120"/>
-              </a:rPr>
-              <a:t>Dialogue trees after Nigar is free: justice vs revenge flags</a:t>
-            </a:r>
-            <a:endParaRPr lang="en-US" sz="2000" dirty="0"/>
-          </a:p>
-          <a:p>
-            <a:pPr marL="342900" indent="-342900">
-              <a:spcAft>
-                <a:spcPts val="1000"/>
-              </a:spcAft>
-              <a:buSzPct val="100000"/>
-              <a:buChar char="•"/>
-            </a:pPr>
-            <a:r>
-              <a:rPr lang="en-US" sz="2000" dirty="0">
-                <a:solidFill>
-                  <a:srgbClr val="F4E6C1"/>
-                </a:solidFill>
-                <a:latin typeface="Georgia" pitchFamily="34" charset="0"/>
-                <a:ea typeface="Georgia" pitchFamily="34" charset="-122"/>
-                <a:cs typeface="Georgia" pitchFamily="34" charset="-120"/>
-              </a:rPr>
-              <a:t>Quest shape: your words change how the keep is remembered</a:t>
+              <a:t>Mounted riding in a valley (click or Ride N / W / S / E)</a:t>
+            </a:r>
+            <a:endParaRPr lang="en-US" sz="2000" dirty="0"/>
+          </a:p>
+          <a:p>
+            <a:pPr marL="342900" indent="-342900">
+              <a:spcAft>
+                <a:spcPts val="1000"/>
+              </a:spcAft>
+              <a:buSzPct val="100000"/>
+              <a:buChar char="•"/>
+            </a:pPr>
+            <a:r>
+              <a:rPr lang="en-US" sz="2000" dirty="0">
+                <a:solidFill>
+                  <a:srgbClr val="F4E6C1"/>
+                </a:solidFill>
+                <a:latin typeface="Georgia" pitchFamily="34" charset="0"/>
+                <a:ea typeface="Georgia" pitchFamily="34" charset="-122"/>
+                <a:cs typeface="Georgia" pitchFamily="34" charset="-120"/>
+              </a:rPr>
+              <a:t>Sword combat with hit timing</a:t>
+            </a:r>
+            <a:endParaRPr lang="en-US" sz="2000" dirty="0"/>
+          </a:p>
+          <a:p>
+            <a:pPr marL="342900" indent="-342900">
+              <a:spcAft>
+                <a:spcPts val="1000"/>
+              </a:spcAft>
+              <a:buSzPct val="100000"/>
+              <a:buChar char="•"/>
+            </a:pPr>
+            <a:r>
+              <a:rPr lang="en-US" sz="2000" dirty="0">
+                <a:solidFill>
+                  <a:srgbClr val="F4E6C1"/>
+                </a:solidFill>
+                <a:latin typeface="Georgia" pitchFamily="34" charset="0"/>
+                <a:ea typeface="Georgia" pitchFamily="34" charset="-122"/>
+                <a:cs typeface="Georgia" pitchFamily="34" charset="-120"/>
+              </a:rPr>
+              <a:t>Poetry combat: recited verses demoralize enemies</a:t>
+            </a:r>
+            <a:endParaRPr lang="en-US" sz="2000" dirty="0"/>
+          </a:p>
+          <a:p>
+            <a:pPr marL="342900" indent="-342900">
+              <a:spcAft>
+                <a:spcPts val="1000"/>
+              </a:spcAft>
+              <a:buSzPct val="100000"/>
+              <a:buChar char="•"/>
+            </a:pPr>
+            <a:r>
+              <a:rPr lang="en-US" sz="2000" dirty="0">
+                <a:solidFill>
+                  <a:srgbClr val="F4E6C1"/>
+                </a:solidFill>
+                <a:latin typeface="Georgia" pitchFamily="34" charset="0"/>
+                <a:ea typeface="Georgia" pitchFamily="34" charset="-122"/>
+                <a:cs typeface="Georgia" pitchFamily="34" charset="-120"/>
+              </a:rPr>
+              <a:t>Ashik saz heals those who stand with song</a:t>
+            </a:r>
+            <a:endParaRPr lang="en-US" sz="2000" dirty="0"/>
+          </a:p>
+          <a:p>
+            <a:pPr marL="342900" indent="-342900">
+              <a:spcAft>
+                <a:spcPts val="1000"/>
+              </a:spcAft>
+              <a:buSzPct val="100000"/>
+              <a:buChar char="•"/>
+            </a:pPr>
+            <a:r>
+              <a:rPr lang="en-US" sz="2000" dirty="0">
+                <a:solidFill>
+                  <a:srgbClr val="F4E6C1"/>
+                </a:solidFill>
+                <a:latin typeface="Georgia" pitchFamily="34" charset="0"/>
+                <a:ea typeface="Georgia" pitchFamily="34" charset="-122"/>
+                <a:cs typeface="Georgia" pitchFamily="34" charset="-120"/>
+              </a:rPr>
+              <a:t>Moral counsel with the band before the last riders</a:t>
             </a:r>
             <a:endParaRPr lang="en-US" sz="2000" dirty="0"/>
           </a:p>
@@ -3305,7 +3606,7 @@
                 <a:ea typeface="Georgia" pitchFamily="34" charset="-122"/>
                 <a:cs typeface="Georgia" pitchFamily="34" charset="-120"/>
               </a:rPr>
-              <a:t>Two-minute playthrough</a:t>
+              <a:t>AI in this build</a:t>
             </a:r>
             <a:endParaRPr lang="en-US" sz="3600" dirty="0"/>
           </a:p>
@@ -3344,7 +3645,7 @@
                 <a:ea typeface="Georgia" pitchFamily="34" charset="-122"/>
                 <a:cs typeface="Georgia" pitchFamily="34" charset="-120"/>
               </a:rPr>
-              <a:t>Record the live game — public/koroglu-two-minute-playthrough.webm</a:t>
+              <a:t>Reactive agents, not a cutscene</a:t>
             </a:r>
             <a:endParaRPr lang="en-US" sz="1800" dirty="0"/>
           </a:p>
@@ -3387,91 +3688,91 @@
                 <a:ea typeface="Georgia" pitchFamily="34" charset="-122"/>
                 <a:cs typeface="Georgia" pitchFamily="34" charset="-120"/>
               </a:rPr>
-              <a:t>0:00 Opening cards: Ali Kishi blinded; you are Koroglu</a:t>
-            </a:r>
-            <a:endParaRPr lang="en-US" sz="2000" dirty="0"/>
-          </a:p>
-          <a:p>
-            <a:pPr marL="342900" indent="-342900">
-              <a:spcAft>
-                <a:spcPts val="1000"/>
-              </a:spcAft>
-              <a:buSzPct val="100000"/>
-              <a:buChar char="•"/>
-            </a:pPr>
-            <a:r>
-              <a:rPr lang="en-US" sz="2000" dirty="0">
-                <a:solidFill>
-                  <a:srgbClr val="F4E6C1"/>
-                </a:solidFill>
-                <a:latin typeface="Georgia" pitchFamily="34" charset="0"/>
-                <a:ea typeface="Georgia" pitchFamily="34" charset="-122"/>
-                <a:cs typeface="Georgia" pitchFamily="34" charset="-120"/>
-              </a:rPr>
-              <a:t>0:06 Hear the father; stand by the ashik (heal); one Verse</a:t>
-            </a:r>
-            <a:endParaRPr lang="en-US" sz="2000" dirty="0"/>
-          </a:p>
-          <a:p>
-            <a:pPr marL="342900" indent="-342900">
-              <a:spcAft>
-                <a:spcPts val="1000"/>
-              </a:spcAft>
-              <a:buSzPct val="100000"/>
-              <a:buChar char="•"/>
-            </a:pPr>
-            <a:r>
-              <a:rPr lang="en-US" sz="2000" dirty="0">
-                <a:solidFill>
-                  <a:srgbClr val="F4E6C1"/>
-                </a:solidFill>
-                <a:latin typeface="Georgia" pitchFamily="34" charset="0"/>
-                <a:ea typeface="Georgia" pitchFamily="34" charset="-122"/>
-                <a:cs typeface="Georgia" pitchFamily="34" charset="-120"/>
-              </a:rPr>
-              <a:t>0:20 Drive tax riders, then gather Ayvaz and Deli Hasan</a:t>
-            </a:r>
-            <a:endParaRPr lang="en-US" sz="2000" dirty="0"/>
-          </a:p>
-          <a:p>
-            <a:pPr marL="342900" indent="-342900">
-              <a:spcAft>
-                <a:spcPts val="1000"/>
-              </a:spcAft>
-              <a:buSzPct val="100000"/>
-              <a:buChar char="•"/>
-            </a:pPr>
-            <a:r>
-              <a:rPr lang="en-US" sz="2000" dirty="0">
-                <a:solidFill>
-                  <a:srgbClr val="F4E6C1"/>
-                </a:solidFill>
-                <a:latin typeface="Georgia" pitchFamily="34" charset="0"/>
-                <a:ea typeface="Georgia" pitchFamily="34" charset="-122"/>
-                <a:cs typeface="Georgia" pitchFamily="34" charset="-120"/>
-              </a:rPr>
-              <a:t>1:20 Captain falls; Nigar walks; kindness is also courage</a:t>
-            </a:r>
-            <a:endParaRPr lang="en-US" sz="2000" dirty="0"/>
-          </a:p>
-          <a:p>
-            <a:pPr marL="342900" indent="-342900">
-              <a:spcAft>
-                <a:spcPts val="1000"/>
-              </a:spcAft>
-              <a:buSzPct val="100000"/>
-              <a:buChar char="•"/>
-            </a:pPr>
-            <a:r>
-              <a:rPr lang="en-US" sz="2000" dirty="0">
-                <a:solidFill>
-                  <a:srgbClr val="F4E6C1"/>
-                </a:solidFill>
-                <a:latin typeface="Georgia" pitchFamily="34" charset="0"/>
-                <a:ea typeface="Georgia" pitchFamily="34" charset="-122"/>
-                <a:cs typeface="Georgia" pitchFamily="34" charset="-120"/>
-              </a:rPr>
-              <a:t>1:45 Green gate, hug, Speak with Nigar — good ending</a:t>
+              <a:t>Ally AI: Deli Hasan and Ayvaz fight at your shoulder</a:t>
+            </a:r>
+            <a:endParaRPr lang="en-US" sz="2000" dirty="0"/>
+          </a:p>
+          <a:p>
+            <a:pPr marL="342900" indent="-342900">
+              <a:spcAft>
+                <a:spcPts val="1000"/>
+              </a:spcAft>
+              <a:buSzPct val="100000"/>
+              <a:buChar char="•"/>
+            </a:pPr>
+            <a:r>
+              <a:rPr lang="en-US" sz="2000" dirty="0">
+                <a:solidFill>
+                  <a:srgbClr val="F4E6C1"/>
+                </a:solidFill>
+                <a:latin typeface="Georgia" pitchFamily="34" charset="0"/>
+                <a:ea typeface="Georgia" pitchFamily="34" charset="-122"/>
+                <a:cs typeface="Georgia" pitchFamily="34" charset="-120"/>
+              </a:rPr>
+              <a:t>Enemy AI: tax riders, sergeant, captain, last keep riders</a:t>
+            </a:r>
+            <a:endParaRPr lang="en-US" sz="2000" dirty="0"/>
+          </a:p>
+          <a:p>
+            <a:pPr marL="342900" indent="-342900">
+              <a:spcAft>
+                <a:spcPts val="1000"/>
+              </a:spcAft>
+              <a:buSzPct val="100000"/>
+              <a:buChar char="•"/>
+            </a:pPr>
+            <a:r>
+              <a:rPr lang="en-US" sz="2000" dirty="0">
+                <a:solidFill>
+                  <a:srgbClr val="F4E6C1"/>
+                </a:solidFill>
+                <a:latin typeface="Georgia" pitchFamily="34" charset="0"/>
+                <a:ea typeface="Georgia" pitchFamily="34" charset="-122"/>
+                <a:cs typeface="Georgia" pitchFamily="34" charset="-120"/>
+              </a:rPr>
+              <a:t>Adaptive pressure: verse slows them; they close when you linger</a:t>
+            </a:r>
+            <a:endParaRPr lang="en-US" sz="2000" dirty="0"/>
+          </a:p>
+          <a:p>
+            <a:pPr marL="342900" indent="-342900">
+              <a:spcAft>
+                <a:spcPts val="1000"/>
+              </a:spcAft>
+              <a:buSzPct val="100000"/>
+              <a:buChar char="•"/>
+            </a:pPr>
+            <a:r>
+              <a:rPr lang="en-US" sz="2000" dirty="0">
+                <a:solidFill>
+                  <a:srgbClr val="F4E6C1"/>
+                </a:solidFill>
+                <a:latin typeface="Georgia" pitchFamily="34" charset="0"/>
+                <a:ea typeface="Georgia" pitchFamily="34" charset="-122"/>
+                <a:cs typeface="Georgia" pitchFamily="34" charset="-120"/>
+              </a:rPr>
+              <a:t>Dialogue trees after Nigar is free: justice vs revenge flags</a:t>
+            </a:r>
+            <a:endParaRPr lang="en-US" sz="2000" dirty="0"/>
+          </a:p>
+          <a:p>
+            <a:pPr marL="342900" indent="-342900">
+              <a:spcAft>
+                <a:spcPts val="1000"/>
+              </a:spcAft>
+              <a:buSzPct val="100000"/>
+              <a:buChar char="•"/>
+            </a:pPr>
+            <a:r>
+              <a:rPr lang="en-US" sz="2000" dirty="0">
+                <a:solidFill>
+                  <a:srgbClr val="F4E6C1"/>
+                </a:solidFill>
+                <a:latin typeface="Georgia" pitchFamily="34" charset="0"/>
+                <a:ea typeface="Georgia" pitchFamily="34" charset="-122"/>
+                <a:cs typeface="Georgia" pitchFamily="34" charset="-120"/>
+              </a:rPr>
+              <a:t>Quest shape: your words change how the keep is remembered</a:t>
             </a:r>
             <a:endParaRPr lang="en-US" sz="2000" dirty="0"/>
           </a:p>
@@ -3542,7 +3843,7 @@
                 <a:ea typeface="Georgia" pitchFamily="34" charset="-122"/>
                 <a:cs typeface="Georgia" pitchFamily="34" charset="-120"/>
               </a:rPr>
-              <a:t>Good ending with Nigar</a:t>
+              <a:t>Two-minute playthrough</a:t>
             </a:r>
             <a:endParaRPr lang="en-US" sz="3600" dirty="0"/>
           </a:p>
@@ -3581,7 +3882,7 @@
                 <a:ea typeface="Georgia" pitchFamily="34" charset="-122"/>
                 <a:cs typeface="Georgia" pitchFamily="34" charset="-120"/>
               </a:rPr>
-              <a:t>Love is not a trophy</a:t>
+              <a:t>Record the live game — public/koroglu-two-minute-playthrough.webm</a:t>
             </a:r>
             <a:endParaRPr lang="en-US" sz="1800" dirty="0"/>
           </a:p>
@@ -3624,91 +3925,91 @@
                 <a:ea typeface="Georgia" pitchFamily="34" charset="-122"/>
                 <a:cs typeface="Georgia" pitchFamily="34" charset="-120"/>
               </a:rPr>
-              <a:t>Win at the green gate: hug still, then Speak with Nigar</a:t>
-            </a:r>
-            <a:endParaRPr lang="en-US" sz="2000" dirty="0"/>
-          </a:p>
-          <a:p>
-            <a:pPr marL="342900" indent="-342900">
-              <a:spcAft>
-                <a:spcPts val="1000"/>
-              </a:spcAft>
-              <a:buSzPct val="100000"/>
-              <a:buChar char="•"/>
-            </a:pPr>
-            <a:r>
-              <a:rPr lang="en-US" sz="2000" dirty="0">
-                <a:solidFill>
-                  <a:srgbClr val="F4E6C1"/>
-                </a:solidFill>
-                <a:latin typeface="Georgia" pitchFamily="34" charset="0"/>
-                <a:ea typeface="Georgia" pitchFamily="34" charset="-122"/>
-                <a:cs typeface="Georgia" pitchFamily="34" charset="-120"/>
-              </a:rPr>
-              <a:t>She refuses to spend the hour as a rescued prize</a:t>
-            </a:r>
-            <a:endParaRPr lang="en-US" sz="2000" dirty="0"/>
-          </a:p>
-          <a:p>
-            <a:pPr marL="342900" indent="-342900">
-              <a:spcAft>
-                <a:spcPts val="1000"/>
-              </a:spcAft>
-              <a:buSzPct val="100000"/>
-              <a:buChar char="•"/>
-            </a:pPr>
-            <a:r>
-              <a:rPr lang="en-US" sz="2000" dirty="0">
-                <a:solidFill>
-                  <a:srgbClr val="F4E6C1"/>
-                </a:solidFill>
-                <a:latin typeface="Georgia" pitchFamily="34" charset="0"/>
-                <a:ea typeface="Georgia" pitchFamily="34" charset="-122"/>
-                <a:cs typeface="Georgia" pitchFamily="34" charset="-120"/>
-              </a:rPr>
-              <a:t>Koroglu answers as her equal — saber, verse, and love</a:t>
-            </a:r>
-            <a:endParaRPr lang="en-US" sz="2000" dirty="0"/>
-          </a:p>
-          <a:p>
-            <a:pPr marL="342900" indent="-342900">
-              <a:spcAft>
-                <a:spcPts val="1000"/>
-              </a:spcAft>
-              <a:buSzPct val="100000"/>
-              <a:buChar char="•"/>
-            </a:pPr>
-            <a:r>
-              <a:rPr lang="en-US" sz="2000" dirty="0">
-                <a:solidFill>
-                  <a:srgbClr val="F4E6C1"/>
-                </a:solidFill>
-                <a:latin typeface="Georgia" pitchFamily="34" charset="0"/>
-                <a:ea typeface="Georgia" pitchFamily="34" charset="-122"/>
-                <a:cs typeface="Georgia" pitchFamily="34" charset="-120"/>
-              </a:rPr>
-              <a:t>Closing card: Good ending — Çamlıbel is a home again</a:t>
-            </a:r>
-            <a:endParaRPr lang="en-US" sz="2000" dirty="0"/>
-          </a:p>
-          <a:p>
-            <a:pPr marL="342900" indent="-342900">
-              <a:spcAft>
-                <a:spcPts val="1000"/>
-              </a:spcAft>
-              <a:buSzPct val="100000"/>
-              <a:buChar char="•"/>
-            </a:pPr>
-            <a:r>
-              <a:rPr lang="en-US" sz="2000" dirty="0">
-                <a:solidFill>
-                  <a:srgbClr val="F4E6C1"/>
-                </a:solidFill>
-                <a:latin typeface="Georgia" pitchFamily="34" charset="0"/>
-                <a:ea typeface="Georgia" pitchFamily="34" charset="-122"/>
-                <a:cs typeface="Georgia" pitchFamily="34" charset="-120"/>
-              </a:rPr>
-              <a:t>The dastan remembers steel and this quiet at the gate</a:t>
+              <a:t>0:00 Opening cards: Ali Kishi blinded; you are Koroglu</a:t>
+            </a:r>
+            <a:endParaRPr lang="en-US" sz="2000" dirty="0"/>
+          </a:p>
+          <a:p>
+            <a:pPr marL="342900" indent="-342900">
+              <a:spcAft>
+                <a:spcPts val="1000"/>
+              </a:spcAft>
+              <a:buSzPct val="100000"/>
+              <a:buChar char="•"/>
+            </a:pPr>
+            <a:r>
+              <a:rPr lang="en-US" sz="2000" dirty="0">
+                <a:solidFill>
+                  <a:srgbClr val="F4E6C1"/>
+                </a:solidFill>
+                <a:latin typeface="Georgia" pitchFamily="34" charset="0"/>
+                <a:ea typeface="Georgia" pitchFamily="34" charset="-122"/>
+                <a:cs typeface="Georgia" pitchFamily="34" charset="-120"/>
+              </a:rPr>
+              <a:t>0:06 Hear the father; stand by the ashik (heal); one Verse</a:t>
+            </a:r>
+            <a:endParaRPr lang="en-US" sz="2000" dirty="0"/>
+          </a:p>
+          <a:p>
+            <a:pPr marL="342900" indent="-342900">
+              <a:spcAft>
+                <a:spcPts val="1000"/>
+              </a:spcAft>
+              <a:buSzPct val="100000"/>
+              <a:buChar char="•"/>
+            </a:pPr>
+            <a:r>
+              <a:rPr lang="en-US" sz="2000" dirty="0">
+                <a:solidFill>
+                  <a:srgbClr val="F4E6C1"/>
+                </a:solidFill>
+                <a:latin typeface="Georgia" pitchFamily="34" charset="0"/>
+                <a:ea typeface="Georgia" pitchFamily="34" charset="-122"/>
+                <a:cs typeface="Georgia" pitchFamily="34" charset="-120"/>
+              </a:rPr>
+              <a:t>0:20 Drive tax riders, then gather Ayvaz and Deli Hasan</a:t>
+            </a:r>
+            <a:endParaRPr lang="en-US" sz="2000" dirty="0"/>
+          </a:p>
+          <a:p>
+            <a:pPr marL="342900" indent="-342900">
+              <a:spcAft>
+                <a:spcPts val="1000"/>
+              </a:spcAft>
+              <a:buSzPct val="100000"/>
+              <a:buChar char="•"/>
+            </a:pPr>
+            <a:r>
+              <a:rPr lang="en-US" sz="2000" dirty="0">
+                <a:solidFill>
+                  <a:srgbClr val="F4E6C1"/>
+                </a:solidFill>
+                <a:latin typeface="Georgia" pitchFamily="34" charset="0"/>
+                <a:ea typeface="Georgia" pitchFamily="34" charset="-122"/>
+                <a:cs typeface="Georgia" pitchFamily="34" charset="-120"/>
+              </a:rPr>
+              <a:t>1:20 Captain falls; Nigar walks; kindness is also courage</a:t>
+            </a:r>
+            <a:endParaRPr lang="en-US" sz="2000" dirty="0"/>
+          </a:p>
+          <a:p>
+            <a:pPr marL="342900" indent="-342900">
+              <a:spcAft>
+                <a:spcPts val="1000"/>
+              </a:spcAft>
+              <a:buSzPct val="100000"/>
+              <a:buChar char="•"/>
+            </a:pPr>
+            <a:r>
+              <a:rPr lang="en-US" sz="2000" dirty="0">
+                <a:solidFill>
+                  <a:srgbClr val="F4E6C1"/>
+                </a:solidFill>
+                <a:latin typeface="Georgia" pitchFamily="34" charset="0"/>
+                <a:ea typeface="Georgia" pitchFamily="34" charset="-122"/>
+                <a:cs typeface="Georgia" pitchFamily="34" charset="-120"/>
+              </a:rPr>
+              <a:t>1:45 Green gate, hug, Speak with Nigar — good ending</a:t>
             </a:r>
             <a:endParaRPr lang="en-US" sz="2000" dirty="0"/>
           </a:p>
@@ -3779,7 +4080,7 @@
                 <a:ea typeface="Georgia" pitchFamily="34" charset="-122"/>
                 <a:cs typeface="Georgia" pitchFamily="34" charset="-120"/>
               </a:rPr>
-              <a:t>What to judge</a:t>
+              <a:t>Good ending with Nigar</a:t>
             </a:r>
             <a:endParaRPr lang="en-US" sz="3600" dirty="0"/>
           </a:p>
@@ -3818,7 +4119,7 @@
                 <a:ea typeface="Georgia" pitchFamily="34" charset="-122"/>
                 <a:cs typeface="Georgia" pitchFamily="34" charset="-120"/>
               </a:rPr>
-              <a:t>Priority when features conflict</a:t>
+              <a:t>Love is not a trophy</a:t>
             </a:r>
             <a:endParaRPr lang="en-US" sz="1800" dirty="0"/>
           </a:p>
@@ -3861,91 +4162,91 @@
                 <a:ea typeface="Georgia" pitchFamily="34" charset="-122"/>
                 <a:cs typeface="Georgia" pitchFamily="34" charset="-120"/>
               </a:rPr>
-              <a:t>Cultural authenticity first</a:t>
-            </a:r>
-            <a:endParaRPr lang="en-US" sz="2000" dirty="0"/>
-          </a:p>
-          <a:p>
-            <a:pPr marL="342900" indent="-342900">
-              <a:spcAft>
-                <a:spcPts val="1000"/>
-              </a:spcAft>
-              <a:buSzPct val="100000"/>
-              <a:buChar char="•"/>
-            </a:pPr>
-            <a:r>
-              <a:rPr lang="en-US" sz="2000" dirty="0">
-                <a:solidFill>
-                  <a:srgbClr val="F4E6C1"/>
-                </a:solidFill>
-                <a:latin typeface="Georgia" pitchFamily="34" charset="0"/>
-                <a:ea typeface="Georgia" pitchFamily="34" charset="-122"/>
-                <a:cs typeface="Georgia" pitchFamily="34" charset="-120"/>
-              </a:rPr>
-              <a:t>Then a playable combat and AI loop</a:t>
-            </a:r>
-            <a:endParaRPr lang="en-US" sz="2000" dirty="0"/>
-          </a:p>
-          <a:p>
-            <a:pPr marL="342900" indent="-342900">
-              <a:spcAft>
-                <a:spcPts val="1000"/>
-              </a:spcAft>
-              <a:buSzPct val="100000"/>
-              <a:buChar char="•"/>
-            </a:pPr>
-            <a:r>
-              <a:rPr lang="en-US" sz="2000" dirty="0">
-                <a:solidFill>
-                  <a:srgbClr val="F4E6C1"/>
-                </a:solidFill>
-                <a:latin typeface="Georgia" pitchFamily="34" charset="0"/>
-                <a:ea typeface="Georgia" pitchFamily="34" charset="-122"/>
-                <a:cs typeface="Georgia" pitchFamily="34" charset="-120"/>
-              </a:rPr>
-              <a:t>Then generative / branching narrative</a:t>
-            </a:r>
-            <a:endParaRPr lang="en-US" sz="2000" dirty="0"/>
-          </a:p>
-          <a:p>
-            <a:pPr marL="342900" indent="-342900">
-              <a:spcAft>
-                <a:spcPts val="1000"/>
-              </a:spcAft>
-              <a:buSzPct val="100000"/>
-              <a:buChar char="•"/>
-            </a:pPr>
-            <a:r>
-              <a:rPr lang="en-US" sz="2000" dirty="0">
-                <a:solidFill>
-                  <a:srgbClr val="F4E6C1"/>
-                </a:solidFill>
-                <a:latin typeface="Georgia" pitchFamily="34" charset="0"/>
-                <a:ea typeface="Georgia" pitchFamily="34" charset="-122"/>
-                <a:cs typeface="Georgia" pitchFamily="34" charset="-120"/>
-              </a:rPr>
-              <a:t>Then polish</a:t>
-            </a:r>
-            <a:endParaRPr lang="en-US" sz="2000" dirty="0"/>
-          </a:p>
-          <a:p>
-            <a:pPr marL="342900" indent="-342900">
-              <a:spcAft>
-                <a:spcPts val="1000"/>
-              </a:spcAft>
-              <a:buSzPct val="100000"/>
-              <a:buChar char="•"/>
-            </a:pPr>
-            <a:r>
-              <a:rPr lang="en-US" sz="2000" dirty="0">
-                <a:solidFill>
-                  <a:srgbClr val="F4E6C1"/>
-                </a:solidFill>
-                <a:latin typeface="Georgia" pitchFamily="34" charset="0"/>
-                <a:ea typeface="Georgia" pitchFamily="34" charset="-122"/>
-                <a:cs typeface="Georgia" pitchFamily="34" charset="-120"/>
-              </a:rPr>
-              <a:t>This prototype proves the loop in a few minutes of play</a:t>
+              <a:t>Win at the green gate: hug still, then Speak with Nigar</a:t>
+            </a:r>
+            <a:endParaRPr lang="en-US" sz="2000" dirty="0"/>
+          </a:p>
+          <a:p>
+            <a:pPr marL="342900" indent="-342900">
+              <a:spcAft>
+                <a:spcPts val="1000"/>
+              </a:spcAft>
+              <a:buSzPct val="100000"/>
+              <a:buChar char="•"/>
+            </a:pPr>
+            <a:r>
+              <a:rPr lang="en-US" sz="2000" dirty="0">
+                <a:solidFill>
+                  <a:srgbClr val="F4E6C1"/>
+                </a:solidFill>
+                <a:latin typeface="Georgia" pitchFamily="34" charset="0"/>
+                <a:ea typeface="Georgia" pitchFamily="34" charset="-122"/>
+                <a:cs typeface="Georgia" pitchFamily="34" charset="-120"/>
+              </a:rPr>
+              <a:t>She refuses to spend the hour as a rescued prize</a:t>
+            </a:r>
+            <a:endParaRPr lang="en-US" sz="2000" dirty="0"/>
+          </a:p>
+          <a:p>
+            <a:pPr marL="342900" indent="-342900">
+              <a:spcAft>
+                <a:spcPts val="1000"/>
+              </a:spcAft>
+              <a:buSzPct val="100000"/>
+              <a:buChar char="•"/>
+            </a:pPr>
+            <a:r>
+              <a:rPr lang="en-US" sz="2000" dirty="0">
+                <a:solidFill>
+                  <a:srgbClr val="F4E6C1"/>
+                </a:solidFill>
+                <a:latin typeface="Georgia" pitchFamily="34" charset="0"/>
+                <a:ea typeface="Georgia" pitchFamily="34" charset="-122"/>
+                <a:cs typeface="Georgia" pitchFamily="34" charset="-120"/>
+              </a:rPr>
+              <a:t>Koroglu answers as her equal — saber, verse, and love</a:t>
+            </a:r>
+            <a:endParaRPr lang="en-US" sz="2000" dirty="0"/>
+          </a:p>
+          <a:p>
+            <a:pPr marL="342900" indent="-342900">
+              <a:spcAft>
+                <a:spcPts val="1000"/>
+              </a:spcAft>
+              <a:buSzPct val="100000"/>
+              <a:buChar char="•"/>
+            </a:pPr>
+            <a:r>
+              <a:rPr lang="en-US" sz="2000" dirty="0">
+                <a:solidFill>
+                  <a:srgbClr val="F4E6C1"/>
+                </a:solidFill>
+                <a:latin typeface="Georgia" pitchFamily="34" charset="0"/>
+                <a:ea typeface="Georgia" pitchFamily="34" charset="-122"/>
+                <a:cs typeface="Georgia" pitchFamily="34" charset="-120"/>
+              </a:rPr>
+              <a:t>Closing card: Good ending — Çamlıbel is a home again</a:t>
+            </a:r>
+            <a:endParaRPr lang="en-US" sz="2000" dirty="0"/>
+          </a:p>
+          <a:p>
+            <a:pPr marL="342900" indent="-342900">
+              <a:spcAft>
+                <a:spcPts val="1000"/>
+              </a:spcAft>
+              <a:buSzPct val="100000"/>
+              <a:buChar char="•"/>
+            </a:pPr>
+            <a:r>
+              <a:rPr lang="en-US" sz="2000" dirty="0">
+                <a:solidFill>
+                  <a:srgbClr val="F4E6C1"/>
+                </a:solidFill>
+                <a:latin typeface="Georgia" pitchFamily="34" charset="0"/>
+                <a:ea typeface="Georgia" pitchFamily="34" charset="-122"/>
+                <a:cs typeface="Georgia" pitchFamily="34" charset="-120"/>
+              </a:rPr>
+              <a:t>The dastan remembers steel and this quiet at the gate</a:t>
             </a:r>
             <a:endParaRPr lang="en-US" sz="2000" dirty="0"/>
           </a:p>

</xml_diff>

<commit_message>
Document play tests and honest failures for the judging prompt.
The deck now says what we actually ran, what broke (WebGL, missing Nigar talk, wrong git branch, models we never shipped), and how that compares to lecture-and-Wikipedia today.

Co-Authored-By: Oyren Agent <contact@oyren.ai>
Co-authored-by: Cursor <cursoragent@cursor.com>
</commit_message>
<xml_diff>
--- a/docs/Koroglu-Epic-Game.pptx
+++ b/docs/Koroglu-Epic-Game.pptx
@@ -16,9 +16,10 @@
     <p:sldId id="264" r:id="rId10"/>
     <p:sldId id="265" r:id="rId11"/>
     <p:sldId id="266" r:id="rId12"/>
+    <p:sldId id="267" r:id="rId13"/>
   </p:sldIdLst>
   <p:notesMasterIdLst>
-    <p:notesMasterId r:id="rId13"/>
+    <p:notesMasterId r:id="rId14"/>
   </p:notesMasterIdLst>
   <p:sldSz cx="12191695" cy="6858000"/>
   <p:notesSz cx="6858000" cy="12191695"/>
@@ -712,6 +713,94 @@
             <a:fld id="{F7021451-1387-4CA6-816F-3879F97B5CBC}" type="slidenum">
               <a:rPr lang="en-US"/>
               <a:t>11</a:t>
+            </a:fld>
+            <a:endParaRPr lang="en-US"/>
+          </a:p>
+        </p:txBody>
+      </p:sp>
+    </p:spTree>
+    <p:extLst>
+      <p:ext uri="{BB962C8B-B14F-4D97-AF65-F5344CB8AC3E}">
+        <p14:creationId xmlns:p14="http://schemas.microsoft.com/office/powerpoint/2010/main" val="1024086991"/>
+      </p:ext>
+    </p:extLst>
+  </p:cSld>
+  <p:clrMapOvr>
+    <a:masterClrMapping/>
+  </p:clrMapOvr>
+</p:notes>
+</file>
+
+<file path=ppt/notesSlides/notesSlide12.xml><?xml version="1.0" encoding="utf-8"?>
+<p:notes xmlns:a="http://schemas.openxmlformats.org/drawingml/2006/main" xmlns:r="http://schemas.openxmlformats.org/officeDocument/2006/relationships" xmlns:p="http://schemas.openxmlformats.org/presentationml/2006/main">
+  <p:cSld>
+    <p:spTree>
+      <p:nvGrpSpPr>
+        <p:cNvPr id="1" name=""/>
+        <p:cNvGrpSpPr/>
+        <p:nvPr/>
+      </p:nvGrpSpPr>
+      <p:grpSpPr>
+        <a:xfrm>
+          <a:off x="0" y="0"/>
+          <a:ext cx="0" cy="0"/>
+          <a:chOff x="0" y="0"/>
+          <a:chExt cx="0" cy="0"/>
+        </a:xfrm>
+      </p:grpSpPr>
+      <p:sp>
+        <p:nvSpPr>
+          <p:cNvPr id="2" name="Slide Image Placeholder 1"/>
+          <p:cNvSpPr>
+            <a:spLocks noGrp="1" noRot="1" noChangeAspect="1"/>
+          </p:cNvSpPr>
+          <p:nvPr>
+            <p:ph type="sldImg"/>
+          </p:nvPr>
+        </p:nvSpPr>
+        <p:spPr/>
+      </p:sp>
+      <p:sp>
+        <p:nvSpPr>
+          <p:cNvPr id="3" name="Notes Placeholder 2"/>
+          <p:cNvSpPr>
+            <a:spLocks noGrp="1"/>
+          </p:cNvSpPr>
+          <p:nvPr>
+            <p:ph type="body" idx="1"/>
+          </p:nvPr>
+        </p:nvSpPr>
+        <p:spPr/>
+        <p:txBody>
+          <a:bodyPr/>
+          <a:lstStyle/>
+          <a:p>
+            <a:r>
+              <a:rPr lang="en-US" dirty="0"/>
+              <a:t/>
+            </a:r>
+            <a:endParaRPr lang="en-US" dirty="0"/>
+          </a:p>
+        </p:txBody>
+      </p:sp>
+      <p:sp>
+        <p:nvSpPr>
+          <p:cNvPr id="4" name="Slide Number Placeholder 3"/>
+          <p:cNvSpPr>
+            <a:spLocks noGrp="1"/>
+          </p:cNvSpPr>
+          <p:nvPr>
+            <p:ph type="sldNum" sz="quarter" idx="10"/>
+          </p:nvPr>
+        </p:nvSpPr>
+        <p:spPr/>
+        <p:txBody>
+          <a:bodyPr/>
+          <a:lstStyle/>
+          <a:p>
+            <a:fld id="{F7021451-1387-4CA6-816F-3879F97B5CBC}" type="slidenum">
+              <a:rPr lang="en-US"/>
+              <a:t>12</a:t>
             </a:fld>
             <a:endParaRPr lang="en-US"/>
           </a:p>
@@ -2010,7 +2099,7 @@
                 <a:ea typeface="Georgia" pitchFamily="34" charset="-122"/>
                 <a:cs typeface="Georgia" pitchFamily="34" charset="-120"/>
               </a:rPr>
-              <a:t>What to judge</a:t>
+              <a:t>What we tested, and what broke</a:t>
             </a:r>
             <a:endParaRPr lang="en-US" sz="3600" dirty="0"/>
           </a:p>
@@ -2049,7 +2138,7 @@
                 <a:ea typeface="Georgia" pitchFamily="34" charset="-122"/>
                 <a:cs typeface="Georgia" pitchFamily="34" charset="-120"/>
               </a:rPr>
-              <a:t>Priority when features conflict</a:t>
+              <a:t>Honest failures score better than silence. No Jest — play tests, a 2-minute recording, shipping checks.</a:t>
             </a:r>
             <a:endParaRPr lang="en-US" sz="1800" dirty="0"/>
           </a:p>
@@ -2092,91 +2181,70 @@
                 <a:ea typeface="Georgia" pitchFamily="34" charset="-122"/>
                 <a:cs typeface="Georgia" pitchFamily="34" charset="-120"/>
               </a:rPr>
-              <a:t>Cultural authenticity first</a:t>
-            </a:r>
-            <a:endParaRPr lang="en-US" sz="2000" dirty="0"/>
-          </a:p>
-          <a:p>
-            <a:pPr marL="342900" indent="-342900">
-              <a:spcAft>
-                <a:spcPts val="1000"/>
-              </a:spcAft>
-              <a:buSzPct val="100000"/>
-              <a:buChar char="•"/>
-            </a:pPr>
-            <a:r>
-              <a:rPr lang="en-US" sz="2000" dirty="0">
-                <a:solidFill>
-                  <a:srgbClr val="F4E6C1"/>
-                </a:solidFill>
-                <a:latin typeface="Georgia" pitchFamily="34" charset="0"/>
-                <a:ea typeface="Georgia" pitchFamily="34" charset="-122"/>
-                <a:cs typeface="Georgia" pitchFamily="34" charset="-120"/>
-              </a:rPr>
-              <a:t>Then a playable combat and AI loop</a:t>
-            </a:r>
-            <a:endParaRPr lang="en-US" sz="2000" dirty="0"/>
-          </a:p>
-          <a:p>
-            <a:pPr marL="342900" indent="-342900">
-              <a:spcAft>
-                <a:spcPts val="1000"/>
-              </a:spcAft>
-              <a:buSzPct val="100000"/>
-              <a:buChar char="•"/>
-            </a:pPr>
-            <a:r>
-              <a:rPr lang="en-US" sz="2000" dirty="0">
-                <a:solidFill>
-                  <a:srgbClr val="F4E6C1"/>
-                </a:solidFill>
-                <a:latin typeface="Georgia" pitchFamily="34" charset="0"/>
-                <a:ea typeface="Georgia" pitchFamily="34" charset="-122"/>
-                <a:cs typeface="Georgia" pitchFamily="34" charset="-120"/>
-              </a:rPr>
-              <a:t>Then generative / branching narrative</a:t>
-            </a:r>
-            <a:endParaRPr lang="en-US" sz="2000" dirty="0"/>
-          </a:p>
-          <a:p>
-            <a:pPr marL="342900" indent="-342900">
-              <a:spcAft>
-                <a:spcPts val="1000"/>
-              </a:spcAft>
-              <a:buSzPct val="100000"/>
-              <a:buChar char="•"/>
-            </a:pPr>
-            <a:r>
-              <a:rPr lang="en-US" sz="2000" dirty="0">
-                <a:solidFill>
-                  <a:srgbClr val="F4E6C1"/>
-                </a:solidFill>
-                <a:latin typeface="Georgia" pitchFamily="34" charset="0"/>
-                <a:ea typeface="Georgia" pitchFamily="34" charset="-122"/>
-                <a:cs typeface="Georgia" pitchFamily="34" charset="-120"/>
-              </a:rPr>
-              <a:t>Then polish</a:t>
-            </a:r>
-            <a:endParaRPr lang="en-US" sz="2000" dirty="0"/>
-          </a:p>
-          <a:p>
-            <a:pPr marL="342900" indent="-342900">
-              <a:spcAft>
-                <a:spcPts val="1000"/>
-              </a:spcAft>
-              <a:buSzPct val="100000"/>
-              <a:buChar char="•"/>
-            </a:pPr>
-            <a:r>
-              <a:rPr lang="en-US" sz="2000" dirty="0">
-                <a:solidFill>
-                  <a:srgbClr val="F4E6C1"/>
-                </a:solidFill>
-                <a:latin typeface="Georgia" pitchFamily="34" charset="0"/>
-                <a:ea typeface="Georgia" pitchFamily="34" charset="-122"/>
-                <a:cs typeface="Georgia" pitchFamily="34" charset="-120"/>
-              </a:rPr>
-              <a:t>This prototype proves the loop in a few minutes of play</a:t>
+              <a:t>Tested: live loop on video; verse + ashik heal; ally join; Nigar counsel; GitHub webm; PowerPoint open.</a:t>
+            </a:r>
+            <a:endParaRPr lang="en-US" sz="2000" dirty="0"/>
+          </a:p>
+          <a:p>
+            <a:pPr marL="342900" indent="-342900">
+              <a:spcAft>
+                <a:spcPts val="1000"/>
+              </a:spcAft>
+              <a:buSzPct val="100000"/>
+              <a:buChar char="•"/>
+            </a:pPr>
+            <a:r>
+              <a:rPr lang="en-US" sz="2000" dirty="0">
+                <a:solidFill>
+                  <a:srgbClr val="F4E6C1"/>
+                </a:solidFill>
+                <a:latin typeface="Georgia" pitchFamily="34" charset="0"/>
+                <a:ea typeface="Georgia" pitchFamily="34" charset="-122"/>
+                <a:cs typeface="Georgia" pitchFamily="34" charset="-120"/>
+              </a:rPr>
+              <a:t>Broke: WebGL white-screen (now falls back to 2D). Hug ending with no Nigar voice (now Good ending talk). Video “missing” because main ≠ this branch. First .pptx XML would not open.</a:t>
+            </a:r>
+            <a:endParaRPr lang="en-US" sz="2000" dirty="0"/>
+          </a:p>
+          <a:p>
+            <a:pPr marL="342900" indent="-342900">
+              <a:spcAft>
+                <a:spcPts val="1000"/>
+              </a:spcAft>
+              <a:buSzPct val="100000"/>
+              <a:buChar char="•"/>
+            </a:pPr>
+            <a:r>
+              <a:rPr lang="en-US" sz="2000" dirty="0">
+                <a:solidFill>
+                  <a:srgbClr val="F4E6C1"/>
+                </a:solidFill>
+                <a:latin typeface="Georgia" pitchFamily="34" charset="0"/>
+                <a:ea typeface="Georgia" pitchFamily="34" charset="-122"/>
+                <a:cs typeface="Georgia" pitchFamily="34" charset="-120"/>
+              </a:rPr>
+              <a:t>Still broken: horses are boxes (not 50 Turkic models). No mounted archery. No live Azerbaijani/Turkmen LLM. Allies bunch — greedy moveToward, not a navmesh.</a:t>
+            </a:r>
+            <a:endParaRPr lang="en-US" sz="2000" dirty="0"/>
+          </a:p>
+          <a:p>
+            <a:pPr marL="342900" indent="-342900">
+              <a:spcAft>
+                <a:spcPts val="1000"/>
+              </a:spcAft>
+              <a:buSzPct val="100000"/>
+              <a:buChar char="•"/>
+            </a:pPr>
+            <a:r>
+              <a:rPr lang="en-US" sz="2000" dirty="0">
+                <a:solidFill>
+                  <a:srgbClr val="F4E6C1"/>
+                </a:solidFill>
+                <a:latin typeface="Georgia" pitchFamily="34" charset="0"/>
+                <a:ea typeface="Georgia" pitchFamily="34" charset="-122"/>
+                <a:cs typeface="Georgia" pitchFamily="34" charset="-120"/>
+              </a:rPr>
+              <a:t>Vs today: lecture/Wikipedia vs a playable two-minute ride. We beat the lecture. We did not beat a finished cultural AAA horse game — and we should not pretend we did.</a:t>
             </a:r>
             <a:endParaRPr lang="en-US" sz="2000" dirty="0"/>
           </a:p>
@@ -2193,6 +2261,243 @@
 <file path=ppt/slides/slide11.xml><?xml version="1.0" encoding="utf-8"?>
 <p:sld xmlns:a="http://schemas.openxmlformats.org/drawingml/2006/main" xmlns:r="http://schemas.openxmlformats.org/officeDocument/2006/relationships" xmlns:p="http://schemas.openxmlformats.org/presentationml/2006/main">
   <p:cSld name="Slide 11">
+    <p:bg>
+      <p:bgPr>
+        <a:solidFill>
+          <a:srgbClr val="1A1208"/>
+        </a:solidFill>
+      </p:bgPr>
+    </p:bg>
+    <p:spTree>
+      <p:nvGrpSpPr>
+        <p:cNvPr id="1" name=""/>
+        <p:cNvGrpSpPr/>
+        <p:nvPr/>
+      </p:nvGrpSpPr>
+      <p:grpSpPr>
+        <a:xfrm>
+          <a:off x="0" y="0"/>
+          <a:ext cx="0" cy="0"/>
+          <a:chOff x="0" y="0"/>
+          <a:chExt cx="0" cy="0"/>
+        </a:xfrm>
+      </p:grpSpPr>
+      <p:sp>
+        <p:nvSpPr>
+          <p:cNvPr id="2" name="Text 0"/>
+          <p:cNvSpPr/>
+          <p:nvPr/>
+        </p:nvSpPr>
+        <p:spPr>
+          <a:xfrm>
+            <a:off x="548640" y="256032"/>
+            <a:ext cx="11064240" cy="777240"/>
+          </a:xfrm>
+          <a:prstGeom prst="rect">
+            <a:avLst/>
+          </a:prstGeom>
+          <a:noFill/>
+          <a:ln/>
+        </p:spPr>
+        <p:txBody>
+          <a:bodyPr wrap="square" rtlCol="0" anchor="ctr"/>
+          <a:lstStyle/>
+          <a:p>
+            <a:pPr indent="0" marL="0">
+              <a:buNone/>
+            </a:pPr>
+            <a:r>
+              <a:rPr lang="en-US" sz="3600" b="1" dirty="0">
+                <a:solidFill>
+                  <a:srgbClr val="E8C64A"/>
+                </a:solidFill>
+                <a:latin typeface="Georgia" pitchFamily="34" charset="0"/>
+                <a:ea typeface="Georgia" pitchFamily="34" charset="-122"/>
+                <a:cs typeface="Georgia" pitchFamily="34" charset="-120"/>
+              </a:rPr>
+              <a:t>What to judge</a:t>
+            </a:r>
+            <a:endParaRPr lang="en-US" sz="3600" dirty="0"/>
+          </a:p>
+        </p:txBody>
+      </p:sp>
+      <p:sp>
+        <p:nvSpPr>
+          <p:cNvPr id="3" name="Text 1"/>
+          <p:cNvSpPr/>
+          <p:nvPr/>
+        </p:nvSpPr>
+        <p:spPr>
+          <a:xfrm>
+            <a:off x="548640" y="1024128"/>
+            <a:ext cx="11064240" cy="457200"/>
+          </a:xfrm>
+          <a:prstGeom prst="rect">
+            <a:avLst/>
+          </a:prstGeom>
+          <a:noFill/>
+          <a:ln/>
+        </p:spPr>
+        <p:txBody>
+          <a:bodyPr wrap="square" rtlCol="0" anchor="ctr"/>
+          <a:lstStyle/>
+          <a:p>
+            <a:pPr indent="0" marL="0">
+              <a:buNone/>
+            </a:pPr>
+            <a:r>
+              <a:rPr lang="en-US" sz="1800" i="1" dirty="0">
+                <a:solidFill>
+                  <a:srgbClr val="C9A227"/>
+                </a:solidFill>
+                <a:latin typeface="Georgia" pitchFamily="34" charset="0"/>
+                <a:ea typeface="Georgia" pitchFamily="34" charset="-122"/>
+                <a:cs typeface="Georgia" pitchFamily="34" charset="-120"/>
+              </a:rPr>
+              <a:t>Priority when features conflict</a:t>
+            </a:r>
+            <a:endParaRPr lang="en-US" sz="1800" dirty="0"/>
+          </a:p>
+        </p:txBody>
+      </p:sp>
+      <p:sp>
+        <p:nvSpPr>
+          <p:cNvPr id="4" name="Text 2"/>
+          <p:cNvSpPr/>
+          <p:nvPr/>
+        </p:nvSpPr>
+        <p:spPr>
+          <a:xfrm>
+            <a:off x="640080" y="1645920"/>
+            <a:ext cx="10972800" cy="4663440"/>
+          </a:xfrm>
+          <a:prstGeom prst="rect">
+            <a:avLst/>
+          </a:prstGeom>
+          <a:noFill/>
+          <a:ln/>
+        </p:spPr>
+        <p:txBody>
+          <a:bodyPr wrap="square" rtlCol="0" anchor="ctr"/>
+          <a:lstStyle/>
+          <a:p>
+            <a:pPr marL="342900" indent="-342900">
+              <a:spcAft>
+                <a:spcPts val="1000"/>
+              </a:spcAft>
+              <a:buSzPct val="100000"/>
+              <a:buChar char="•"/>
+            </a:pPr>
+            <a:r>
+              <a:rPr lang="en-US" sz="2000" dirty="0">
+                <a:solidFill>
+                  <a:srgbClr val="F4E6C1"/>
+                </a:solidFill>
+                <a:latin typeface="Georgia" pitchFamily="34" charset="0"/>
+                <a:ea typeface="Georgia" pitchFamily="34" charset="-122"/>
+                <a:cs typeface="Georgia" pitchFamily="34" charset="-120"/>
+              </a:rPr>
+              <a:t>Cultural authenticity first</a:t>
+            </a:r>
+            <a:endParaRPr lang="en-US" sz="2000" dirty="0"/>
+          </a:p>
+          <a:p>
+            <a:pPr marL="342900" indent="-342900">
+              <a:spcAft>
+                <a:spcPts val="1000"/>
+              </a:spcAft>
+              <a:buSzPct val="100000"/>
+              <a:buChar char="•"/>
+            </a:pPr>
+            <a:r>
+              <a:rPr lang="en-US" sz="2000" dirty="0">
+                <a:solidFill>
+                  <a:srgbClr val="F4E6C1"/>
+                </a:solidFill>
+                <a:latin typeface="Georgia" pitchFamily="34" charset="0"/>
+                <a:ea typeface="Georgia" pitchFamily="34" charset="-122"/>
+                <a:cs typeface="Georgia" pitchFamily="34" charset="-120"/>
+              </a:rPr>
+              <a:t>Then a playable combat and AI loop</a:t>
+            </a:r>
+            <a:endParaRPr lang="en-US" sz="2000" dirty="0"/>
+          </a:p>
+          <a:p>
+            <a:pPr marL="342900" indent="-342900">
+              <a:spcAft>
+                <a:spcPts val="1000"/>
+              </a:spcAft>
+              <a:buSzPct val="100000"/>
+              <a:buChar char="•"/>
+            </a:pPr>
+            <a:r>
+              <a:rPr lang="en-US" sz="2000" dirty="0">
+                <a:solidFill>
+                  <a:srgbClr val="F4E6C1"/>
+                </a:solidFill>
+                <a:latin typeface="Georgia" pitchFamily="34" charset="0"/>
+                <a:ea typeface="Georgia" pitchFamily="34" charset="-122"/>
+                <a:cs typeface="Georgia" pitchFamily="34" charset="-120"/>
+              </a:rPr>
+              <a:t>Then generative / branching narrative</a:t>
+            </a:r>
+            <a:endParaRPr lang="en-US" sz="2000" dirty="0"/>
+          </a:p>
+          <a:p>
+            <a:pPr marL="342900" indent="-342900">
+              <a:spcAft>
+                <a:spcPts val="1000"/>
+              </a:spcAft>
+              <a:buSzPct val="100000"/>
+              <a:buChar char="•"/>
+            </a:pPr>
+            <a:r>
+              <a:rPr lang="en-US" sz="2000" dirty="0">
+                <a:solidFill>
+                  <a:srgbClr val="F4E6C1"/>
+                </a:solidFill>
+                <a:latin typeface="Georgia" pitchFamily="34" charset="0"/>
+                <a:ea typeface="Georgia" pitchFamily="34" charset="-122"/>
+                <a:cs typeface="Georgia" pitchFamily="34" charset="-120"/>
+              </a:rPr>
+              <a:t>Then polish</a:t>
+            </a:r>
+            <a:endParaRPr lang="en-US" sz="2000" dirty="0"/>
+          </a:p>
+          <a:p>
+            <a:pPr marL="342900" indent="-342900">
+              <a:spcAft>
+                <a:spcPts val="1000"/>
+              </a:spcAft>
+              <a:buSzPct val="100000"/>
+              <a:buChar char="•"/>
+            </a:pPr>
+            <a:r>
+              <a:rPr lang="en-US" sz="2000" dirty="0">
+                <a:solidFill>
+                  <a:srgbClr val="F4E6C1"/>
+                </a:solidFill>
+                <a:latin typeface="Georgia" pitchFamily="34" charset="0"/>
+                <a:ea typeface="Georgia" pitchFamily="34" charset="-122"/>
+                <a:cs typeface="Georgia" pitchFamily="34" charset="-120"/>
+              </a:rPr>
+              <a:t>This prototype proves the loop in a few minutes of play</a:t>
+            </a:r>
+            <a:endParaRPr lang="en-US" sz="2000" dirty="0"/>
+          </a:p>
+        </p:txBody>
+      </p:sp>
+    </p:spTree>
+  </p:cSld>
+  <p:clrMapOvr>
+    <a:masterClrMapping/>
+  </p:clrMapOvr>
+</p:sld>
+</file>
+
+<file path=ppt/slides/slide12.xml><?xml version="1.0" encoding="utf-8"?>
+<p:sld xmlns:a="http://schemas.openxmlformats.org/drawingml/2006/main" xmlns:r="http://schemas.openxmlformats.org/officeDocument/2006/relationships" xmlns:p="http://schemas.openxmlformats.org/presentationml/2006/main">
+  <p:cSld name="Slide 12">
     <p:bg>
       <p:bgPr>
         <a:solidFill>

</xml_diff>